<commit_message>
feat: streamline to 2-workflow demo with inline doc previews
- Remove Workflow III (compliance engine) — focus on synth data + deliverables
- Add inline document preview viewers for DOCX (mammoth) and PPTX (position-aware renderer)
- Remove confidence threshold slider (AI determines confidence post-generation)
- Make backend URL configurable via BACKEND_URL env var for Cloud Run deploy
- Add updated demo brief prompt (V2) for Gemini playbook generation
- Update NovaCrest demo assets (consolidated due diligence pack PDF)
</commit_message>
<xml_diff>
--- a/frontend/demo_data/phase2_sample_deck.pptx
+++ b/frontend/demo_data/phase2_sample_deck.pptx
@@ -6,8 +6,14 @@
   </p:sldMasterIdLst>
   <p:sldIdLst>
     <p:sldId id="256" r:id="rId7"/>
+    <p:sldId id="257" r:id="rId8"/>
+    <p:sldId id="258" r:id="rId9"/>
+    <p:sldId id="259" r:id="rId10"/>
+    <p:sldId id="260" r:id="rId11"/>
+    <p:sldId id="261" r:id="rId12"/>
+    <p:sldId id="262" r:id="rId13"/>
   </p:sldIdLst>
-  <p:sldSz cx="9144000" cy="6858000" type="screen4x3"/>
+  <p:sldSz cx="12191695" cy="6858000" type="screen4x3"/>
   <p:notesSz cx="6858000" cy="9144000"/>
   <p:defaultTextStyle>
     <a:defPPr>
@@ -3081,6 +3087,14 @@
 <file path=ppt/slides/slide1.xml><?xml version="1.0" encoding="utf-8"?>
 <p:sld xmlns:a="http://schemas.openxmlformats.org/drawingml/2006/main" xmlns:p="http://schemas.openxmlformats.org/presentationml/2006/main" xmlns:r="http://schemas.openxmlformats.org/officeDocument/2006/relationships">
   <p:cSld>
+    <p:bg>
+      <p:bgPr>
+        <a:solidFill>
+          <a:srgbClr val="0A1F0D"/>
+        </a:solidFill>
+        <a:effectLst/>
+      </p:bgPr>
+    </p:bg>
     <p:spTree>
       <p:nvGrpSpPr>
         <p:cNvPr id="1" name=""/>
@@ -3090,42 +3104,3756 @@
       <p:grpSpPr/>
       <p:sp>
         <p:nvSpPr>
-          <p:cNvPr id="2" name="Title 1"/>
-          <p:cNvSpPr>
-            <a:spLocks noGrp="1"/>
-          </p:cNvSpPr>
-          <p:nvPr>
-            <p:ph type="ctrTitle"/>
-          </p:nvPr>
-        </p:nvSpPr>
-        <p:spPr/>
-        <p:txBody>
-          <a:bodyPr/>
-          <a:lstStyle/>
-          <a:p>
-            <a:r>
-              <a:t>Demo Exec Deck</a:t>
-            </a:r>
-          </a:p>
-        </p:txBody>
-      </p:sp>
-      <p:sp>
-        <p:nvSpPr>
-          <p:cNvPr id="3" name="Subtitle 2"/>
-          <p:cNvSpPr>
-            <a:spLocks noGrp="1"/>
-          </p:cNvSpPr>
-          <p:nvPr>
-            <p:ph type="subTitle" idx="1"/>
-          </p:nvPr>
-        </p:nvSpPr>
-        <p:spPr/>
-        <p:txBody>
-          <a:bodyPr/>
-          <a:lstStyle/>
-          <a:p>
-            <a:r>
-              <a:t>Generated by Tracelight</a:t>
+          <p:cNvPr id="2" name="TextBox 1"/>
+          <p:cNvSpPr txBox="1"/>
+          <p:nvPr/>
+        </p:nvSpPr>
+        <p:spPr>
+          <a:xfrm>
+            <a:off x="914400" y="1371600"/>
+            <a:ext cx="10058400" cy="914400"/>
+          </a:xfrm>
+          <a:prstGeom prst="rect">
+            <a:avLst/>
+          </a:prstGeom>
+          <a:noFill/>
+        </p:spPr>
+        <p:txBody>
+          <a:bodyPr wrap="square">
+            <a:spAutoFit/>
+          </a:bodyPr>
+          <a:lstStyle/>
+          <a:p>
+            <a:pPr algn="l">
+              <a:defRPr sz="1400" b="1">
+                <a:solidFill>
+                  <a:srgbClr val="4CAF50"/>
+                </a:solidFill>
+              </a:defRPr>
+            </a:pPr>
+            <a:r>
+              <a:t>INVESTMENT COMMITTEE PRESENTATION</a:t>
+            </a:r>
+          </a:p>
+        </p:txBody>
+      </p:sp>
+      <p:sp>
+        <p:nvSpPr>
+          <p:cNvPr id="3" name="TextBox 2"/>
+          <p:cNvSpPr txBox="1"/>
+          <p:nvPr/>
+        </p:nvSpPr>
+        <p:spPr>
+          <a:xfrm>
+            <a:off x="914400" y="2011680"/>
+            <a:ext cx="10058400" cy="1371600"/>
+          </a:xfrm>
+          <a:prstGeom prst="rect">
+            <a:avLst/>
+          </a:prstGeom>
+          <a:noFill/>
+        </p:spPr>
+        <p:txBody>
+          <a:bodyPr wrap="square">
+            <a:spAutoFit/>
+          </a:bodyPr>
+          <a:lstStyle/>
+          <a:p>
+            <a:pPr algn="l">
+              <a:defRPr sz="4400" b="1">
+                <a:solidFill>
+                  <a:srgbClr val="FFFFFF"/>
+                </a:solidFill>
+              </a:defRPr>
+            </a:pPr>
+            <a:r>
+              <a:t>NovaCrest Analytics</a:t>
+            </a:r>
+          </a:p>
+        </p:txBody>
+      </p:sp>
+      <p:sp>
+        <p:nvSpPr>
+          <p:cNvPr id="4" name="TextBox 3"/>
+          <p:cNvSpPr txBox="1"/>
+          <p:nvPr/>
+        </p:nvSpPr>
+        <p:spPr>
+          <a:xfrm>
+            <a:off x="914400" y="3474720"/>
+            <a:ext cx="10058400" cy="731520"/>
+          </a:xfrm>
+          <a:prstGeom prst="rect">
+            <a:avLst/>
+          </a:prstGeom>
+          <a:noFill/>
+        </p:spPr>
+        <p:txBody>
+          <a:bodyPr wrap="square">
+            <a:spAutoFit/>
+          </a:bodyPr>
+          <a:lstStyle/>
+          <a:p>
+            <a:pPr algn="l">
+              <a:defRPr sz="2000" b="0">
+                <a:solidFill>
+                  <a:srgbClr val="E8F5E9"/>
+                </a:solidFill>
+              </a:defRPr>
+            </a:pPr>
+            <a:r>
+              <a:t>$85M Growth Equity Investment  |  30% Minority Stake  |  $283M Pre-Money</a:t>
+            </a:r>
+          </a:p>
+        </p:txBody>
+      </p:sp>
+      <p:sp>
+        <p:nvSpPr>
+          <p:cNvPr id="5" name="TextBox 4"/>
+          <p:cNvSpPr txBox="1"/>
+          <p:nvPr/>
+        </p:nvSpPr>
+        <p:spPr>
+          <a:xfrm>
+            <a:off x="914400" y="5029200"/>
+            <a:ext cx="10058400" cy="731520"/>
+          </a:xfrm>
+          <a:prstGeom prst="rect">
+            <a:avLst/>
+          </a:prstGeom>
+          <a:noFill/>
+        </p:spPr>
+        <p:txBody>
+          <a:bodyPr wrap="square">
+            <a:spAutoFit/>
+          </a:bodyPr>
+          <a:lstStyle/>
+          <a:p>
+            <a:pPr algn="l">
+              <a:defRPr sz="1400" b="0">
+                <a:solidFill>
+                  <a:srgbClr val="999999"/>
+                </a:solidFill>
+              </a:defRPr>
+            </a:pPr>
+            <a:r>
+              <a:t>Prepared by Meridian Growth Partners  |  March 2026  |  CONFIDENTIAL</a:t>
+            </a:r>
+          </a:p>
+        </p:txBody>
+      </p:sp>
+    </p:spTree>
+  </p:cSld>
+  <p:clrMapOvr>
+    <a:masterClrMapping/>
+  </p:clrMapOvr>
+</p:sld>
+</file>
+
+<file path=ppt/slides/slide2.xml><?xml version="1.0" encoding="utf-8"?>
+<p:sld xmlns:a="http://schemas.openxmlformats.org/drawingml/2006/main" xmlns:p="http://schemas.openxmlformats.org/presentationml/2006/main" xmlns:r="http://schemas.openxmlformats.org/officeDocument/2006/relationships">
+  <p:cSld>
+    <p:bg>
+      <p:bgPr>
+        <a:solidFill>
+          <a:srgbClr val="0A1F0D"/>
+        </a:solidFill>
+        <a:effectLst/>
+      </p:bgPr>
+    </p:bg>
+    <p:spTree>
+      <p:nvGrpSpPr>
+        <p:cNvPr id="1" name=""/>
+        <p:cNvGrpSpPr/>
+        <p:nvPr/>
+      </p:nvGrpSpPr>
+      <p:grpSpPr/>
+      <p:sp>
+        <p:nvSpPr>
+          <p:cNvPr id="2" name="TextBox 1"/>
+          <p:cNvSpPr txBox="1"/>
+          <p:nvPr/>
+        </p:nvSpPr>
+        <p:spPr>
+          <a:xfrm>
+            <a:off x="731520" y="365760"/>
+            <a:ext cx="10058400" cy="640080"/>
+          </a:xfrm>
+          <a:prstGeom prst="rect">
+            <a:avLst/>
+          </a:prstGeom>
+          <a:noFill/>
+        </p:spPr>
+        <p:txBody>
+          <a:bodyPr wrap="square">
+            <a:spAutoFit/>
+          </a:bodyPr>
+          <a:lstStyle/>
+          <a:p>
+            <a:pPr algn="l">
+              <a:defRPr sz="1400" b="1">
+                <a:solidFill>
+                  <a:srgbClr val="4CAF50"/>
+                </a:solidFill>
+              </a:defRPr>
+            </a:pPr>
+            <a:r>
+              <a:t>EXECUTIVE SUMMARY</a:t>
+            </a:r>
+          </a:p>
+        </p:txBody>
+      </p:sp>
+      <p:sp>
+        <p:nvSpPr>
+          <p:cNvPr id="3" name="TextBox 2"/>
+          <p:cNvSpPr txBox="1"/>
+          <p:nvPr/>
+        </p:nvSpPr>
+        <p:spPr>
+          <a:xfrm>
+            <a:off x="731520" y="822960"/>
+            <a:ext cx="10058400" cy="457200"/>
+          </a:xfrm>
+          <a:prstGeom prst="rect">
+            <a:avLst/>
+          </a:prstGeom>
+          <a:noFill/>
+        </p:spPr>
+        <p:txBody>
+          <a:bodyPr wrap="square">
+            <a:spAutoFit/>
+          </a:bodyPr>
+          <a:lstStyle/>
+          <a:p>
+            <a:pPr algn="l">
+              <a:defRPr sz="2800" b="1">
+                <a:solidFill>
+                  <a:srgbClr val="FFFFFF"/>
+                </a:solidFill>
+              </a:defRPr>
+            </a:pPr>
+            <a:r>
+              <a:t>Recommendation: Proceed with Investment</a:t>
+            </a:r>
+          </a:p>
+        </p:txBody>
+      </p:sp>
+      <p:sp>
+        <p:nvSpPr>
+          <p:cNvPr id="4" name="TextBox 3"/>
+          <p:cNvSpPr txBox="1"/>
+          <p:nvPr/>
+        </p:nvSpPr>
+        <p:spPr>
+          <a:xfrm>
+            <a:off x="731520" y="1645920"/>
+            <a:ext cx="1645920" cy="548640"/>
+          </a:xfrm>
+          <a:prstGeom prst="rect">
+            <a:avLst/>
+          </a:prstGeom>
+          <a:noFill/>
+        </p:spPr>
+        <p:txBody>
+          <a:bodyPr wrap="square">
+            <a:spAutoFit/>
+          </a:bodyPr>
+          <a:lstStyle/>
+          <a:p>
+            <a:pPr algn="ctr">
+              <a:defRPr sz="3200" b="1">
+                <a:solidFill>
+                  <a:srgbClr val="4CAF50"/>
+                </a:solidFill>
+              </a:defRPr>
+            </a:pPr>
+            <a:r>
+              <a:t>$31M</a:t>
+            </a:r>
+          </a:p>
+        </p:txBody>
+      </p:sp>
+      <p:sp>
+        <p:nvSpPr>
+          <p:cNvPr id="5" name="TextBox 4"/>
+          <p:cNvSpPr txBox="1"/>
+          <p:nvPr/>
+        </p:nvSpPr>
+        <p:spPr>
+          <a:xfrm>
+            <a:off x="731520" y="2194560"/>
+            <a:ext cx="1645920" cy="365760"/>
+          </a:xfrm>
+          <a:prstGeom prst="rect">
+            <a:avLst/>
+          </a:prstGeom>
+          <a:noFill/>
+        </p:spPr>
+        <p:txBody>
+          <a:bodyPr wrap="square">
+            <a:spAutoFit/>
+          </a:bodyPr>
+          <a:lstStyle/>
+          <a:p>
+            <a:pPr algn="ctr">
+              <a:defRPr sz="1200" b="0">
+                <a:solidFill>
+                  <a:srgbClr val="999999"/>
+                </a:solidFill>
+              </a:defRPr>
+            </a:pPr>
+            <a:r>
+              <a:t>ARR (2025)</a:t>
+            </a:r>
+          </a:p>
+        </p:txBody>
+      </p:sp>
+      <p:sp>
+        <p:nvSpPr>
+          <p:cNvPr id="6" name="TextBox 5"/>
+          <p:cNvSpPr txBox="1"/>
+          <p:nvPr/>
+        </p:nvSpPr>
+        <p:spPr>
+          <a:xfrm>
+            <a:off x="2560320" y="1645920"/>
+            <a:ext cx="1645920" cy="548640"/>
+          </a:xfrm>
+          <a:prstGeom prst="rect">
+            <a:avLst/>
+          </a:prstGeom>
+          <a:noFill/>
+        </p:spPr>
+        <p:txBody>
+          <a:bodyPr wrap="square">
+            <a:spAutoFit/>
+          </a:bodyPr>
+          <a:lstStyle/>
+          <a:p>
+            <a:pPr algn="ctr">
+              <a:defRPr sz="3200" b="1">
+                <a:solidFill>
+                  <a:srgbClr val="4CAF50"/>
+                </a:solidFill>
+              </a:defRPr>
+            </a:pPr>
+            <a:r>
+              <a:t>72%</a:t>
+            </a:r>
+          </a:p>
+        </p:txBody>
+      </p:sp>
+      <p:sp>
+        <p:nvSpPr>
+          <p:cNvPr id="7" name="TextBox 6"/>
+          <p:cNvSpPr txBox="1"/>
+          <p:nvPr/>
+        </p:nvSpPr>
+        <p:spPr>
+          <a:xfrm>
+            <a:off x="2560320" y="2194560"/>
+            <a:ext cx="1645920" cy="365760"/>
+          </a:xfrm>
+          <a:prstGeom prst="rect">
+            <a:avLst/>
+          </a:prstGeom>
+          <a:noFill/>
+        </p:spPr>
+        <p:txBody>
+          <a:bodyPr wrap="square">
+            <a:spAutoFit/>
+          </a:bodyPr>
+          <a:lstStyle/>
+          <a:p>
+            <a:pPr algn="ctr">
+              <a:defRPr sz="1200" b="0">
+                <a:solidFill>
+                  <a:srgbClr val="999999"/>
+                </a:solidFill>
+              </a:defRPr>
+            </a:pPr>
+            <a:r>
+              <a:t>YoY Growth</a:t>
+            </a:r>
+          </a:p>
+        </p:txBody>
+      </p:sp>
+      <p:sp>
+        <p:nvSpPr>
+          <p:cNvPr id="8" name="TextBox 7"/>
+          <p:cNvSpPr txBox="1"/>
+          <p:nvPr/>
+        </p:nvSpPr>
+        <p:spPr>
+          <a:xfrm>
+            <a:off x="4389120" y="1645920"/>
+            <a:ext cx="1645920" cy="548640"/>
+          </a:xfrm>
+          <a:prstGeom prst="rect">
+            <a:avLst/>
+          </a:prstGeom>
+          <a:noFill/>
+        </p:spPr>
+        <p:txBody>
+          <a:bodyPr wrap="square">
+            <a:spAutoFit/>
+          </a:bodyPr>
+          <a:lstStyle/>
+          <a:p>
+            <a:pPr algn="ctr">
+              <a:defRPr sz="3200" b="1">
+                <a:solidFill>
+                  <a:srgbClr val="4CAF50"/>
+                </a:solidFill>
+              </a:defRPr>
+            </a:pPr>
+            <a:r>
+              <a:t>78%</a:t>
+            </a:r>
+          </a:p>
+        </p:txBody>
+      </p:sp>
+      <p:sp>
+        <p:nvSpPr>
+          <p:cNvPr id="9" name="TextBox 8"/>
+          <p:cNvSpPr txBox="1"/>
+          <p:nvPr/>
+        </p:nvSpPr>
+        <p:spPr>
+          <a:xfrm>
+            <a:off x="4389120" y="2194560"/>
+            <a:ext cx="1645920" cy="365760"/>
+          </a:xfrm>
+          <a:prstGeom prst="rect">
+            <a:avLst/>
+          </a:prstGeom>
+          <a:noFill/>
+        </p:spPr>
+        <p:txBody>
+          <a:bodyPr wrap="square">
+            <a:spAutoFit/>
+          </a:bodyPr>
+          <a:lstStyle/>
+          <a:p>
+            <a:pPr algn="ctr">
+              <a:defRPr sz="1200" b="0">
+                <a:solidFill>
+                  <a:srgbClr val="999999"/>
+                </a:solidFill>
+              </a:defRPr>
+            </a:pPr>
+            <a:r>
+              <a:t>Gross Margin</a:t>
+            </a:r>
+          </a:p>
+        </p:txBody>
+      </p:sp>
+      <p:sp>
+        <p:nvSpPr>
+          <p:cNvPr id="10" name="TextBox 9"/>
+          <p:cNvSpPr txBox="1"/>
+          <p:nvPr/>
+        </p:nvSpPr>
+        <p:spPr>
+          <a:xfrm>
+            <a:off x="6217920" y="1645920"/>
+            <a:ext cx="1645920" cy="548640"/>
+          </a:xfrm>
+          <a:prstGeom prst="rect">
+            <a:avLst/>
+          </a:prstGeom>
+          <a:noFill/>
+        </p:spPr>
+        <p:txBody>
+          <a:bodyPr wrap="square">
+            <a:spAutoFit/>
+          </a:bodyPr>
+          <a:lstStyle/>
+          <a:p>
+            <a:pPr algn="ctr">
+              <a:defRPr sz="3200" b="1">
+                <a:solidFill>
+                  <a:srgbClr val="4CAF50"/>
+                </a:solidFill>
+              </a:defRPr>
+            </a:pPr>
+            <a:r>
+              <a:t>135%</a:t>
+            </a:r>
+          </a:p>
+        </p:txBody>
+      </p:sp>
+      <p:sp>
+        <p:nvSpPr>
+          <p:cNvPr id="11" name="TextBox 10"/>
+          <p:cNvSpPr txBox="1"/>
+          <p:nvPr/>
+        </p:nvSpPr>
+        <p:spPr>
+          <a:xfrm>
+            <a:off x="6217920" y="2194560"/>
+            <a:ext cx="1645920" cy="365760"/>
+          </a:xfrm>
+          <a:prstGeom prst="rect">
+            <a:avLst/>
+          </a:prstGeom>
+          <a:noFill/>
+        </p:spPr>
+        <p:txBody>
+          <a:bodyPr wrap="square">
+            <a:spAutoFit/>
+          </a:bodyPr>
+          <a:lstStyle/>
+          <a:p>
+            <a:pPr algn="ctr">
+              <a:defRPr sz="1200" b="0">
+                <a:solidFill>
+                  <a:srgbClr val="999999"/>
+                </a:solidFill>
+              </a:defRPr>
+            </a:pPr>
+            <a:r>
+              <a:t>Net Retention</a:t>
+            </a:r>
+          </a:p>
+        </p:txBody>
+      </p:sp>
+      <p:sp>
+        <p:nvSpPr>
+          <p:cNvPr id="12" name="TextBox 11"/>
+          <p:cNvSpPr txBox="1"/>
+          <p:nvPr/>
+        </p:nvSpPr>
+        <p:spPr>
+          <a:xfrm>
+            <a:off x="8046720" y="1645920"/>
+            <a:ext cx="1645920" cy="548640"/>
+          </a:xfrm>
+          <a:prstGeom prst="rect">
+            <a:avLst/>
+          </a:prstGeom>
+          <a:noFill/>
+        </p:spPr>
+        <p:txBody>
+          <a:bodyPr wrap="square">
+            <a:spAutoFit/>
+          </a:bodyPr>
+          <a:lstStyle/>
+          <a:p>
+            <a:pPr algn="ctr">
+              <a:defRPr sz="3200" b="1">
+                <a:solidFill>
+                  <a:srgbClr val="4CAF50"/>
+                </a:solidFill>
+              </a:defRPr>
+            </a:pPr>
+            <a:r>
+              <a:t>54</a:t>
+            </a:r>
+          </a:p>
+        </p:txBody>
+      </p:sp>
+      <p:sp>
+        <p:nvSpPr>
+          <p:cNvPr id="13" name="TextBox 12"/>
+          <p:cNvSpPr txBox="1"/>
+          <p:nvPr/>
+        </p:nvSpPr>
+        <p:spPr>
+          <a:xfrm>
+            <a:off x="8046720" y="2194560"/>
+            <a:ext cx="1645920" cy="365760"/>
+          </a:xfrm>
+          <a:prstGeom prst="rect">
+            <a:avLst/>
+          </a:prstGeom>
+          <a:noFill/>
+        </p:spPr>
+        <p:txBody>
+          <a:bodyPr wrap="square">
+            <a:spAutoFit/>
+          </a:bodyPr>
+          <a:lstStyle/>
+          <a:p>
+            <a:pPr algn="ctr">
+              <a:defRPr sz="1200" b="0">
+                <a:solidFill>
+                  <a:srgbClr val="999999"/>
+                </a:solidFill>
+              </a:defRPr>
+            </a:pPr>
+            <a:r>
+              <a:t>Rule of 40</a:t>
+            </a:r>
+          </a:p>
+        </p:txBody>
+      </p:sp>
+      <p:sp>
+        <p:nvSpPr>
+          <p:cNvPr id="14" name="TextBox 13"/>
+          <p:cNvSpPr txBox="1"/>
+          <p:nvPr/>
+        </p:nvSpPr>
+        <p:spPr>
+          <a:xfrm>
+            <a:off x="9875520" y="1645920"/>
+            <a:ext cx="1645920" cy="548640"/>
+          </a:xfrm>
+          <a:prstGeom prst="rect">
+            <a:avLst/>
+          </a:prstGeom>
+          <a:noFill/>
+        </p:spPr>
+        <p:txBody>
+          <a:bodyPr wrap="square">
+            <a:spAutoFit/>
+          </a:bodyPr>
+          <a:lstStyle/>
+          <a:p>
+            <a:pPr algn="ctr">
+              <a:defRPr sz="3200" b="1">
+                <a:solidFill>
+                  <a:srgbClr val="4CAF50"/>
+                </a:solidFill>
+              </a:defRPr>
+            </a:pPr>
+            <a:r>
+              <a:t>14 mo</a:t>
+            </a:r>
+          </a:p>
+        </p:txBody>
+      </p:sp>
+      <p:sp>
+        <p:nvSpPr>
+          <p:cNvPr id="15" name="TextBox 14"/>
+          <p:cNvSpPr txBox="1"/>
+          <p:nvPr/>
+        </p:nvSpPr>
+        <p:spPr>
+          <a:xfrm>
+            <a:off x="9875520" y="2194560"/>
+            <a:ext cx="1645920" cy="365760"/>
+          </a:xfrm>
+          <a:prstGeom prst="rect">
+            <a:avLst/>
+          </a:prstGeom>
+          <a:noFill/>
+        </p:spPr>
+        <p:txBody>
+          <a:bodyPr wrap="square">
+            <a:spAutoFit/>
+          </a:bodyPr>
+          <a:lstStyle/>
+          <a:p>
+            <a:pPr algn="ctr">
+              <a:defRPr sz="1200" b="0">
+                <a:solidFill>
+                  <a:srgbClr val="999999"/>
+                </a:solidFill>
+              </a:defRPr>
+            </a:pPr>
+            <a:r>
+              <a:t>CAC Payback</a:t>
+            </a:r>
+          </a:p>
+        </p:txBody>
+      </p:sp>
+      <p:sp>
+        <p:nvSpPr>
+          <p:cNvPr id="16" name="TextBox 15"/>
+          <p:cNvSpPr txBox="1"/>
+          <p:nvPr/>
+        </p:nvSpPr>
+        <p:spPr>
+          <a:xfrm>
+            <a:off x="731520" y="2926080"/>
+            <a:ext cx="10515600" cy="3657600"/>
+          </a:xfrm>
+          <a:prstGeom prst="rect">
+            <a:avLst/>
+          </a:prstGeom>
+          <a:noFill/>
+        </p:spPr>
+        <p:txBody>
+          <a:bodyPr wrap="square">
+            <a:spAutoFit/>
+          </a:bodyPr>
+          <a:lstStyle/>
+          <a:p>
+            <a:pPr>
+              <a:spcAft>
+                <a:spcPts val="400"/>
+              </a:spcAft>
+              <a:defRPr sz="1600" b="0">
+                <a:solidFill>
+                  <a:srgbClr val="E8F5E9"/>
+                </a:solidFill>
+              </a:defRPr>
+            </a:pPr>
+            <a:r>
+              <a:t>B2B SaaS financial data infrastructure — serves banks, asset managers, insurance companies</a:t>
+            </a:r>
+          </a:p>
+          <a:p>
+            <a:pPr>
+              <a:spcAft>
+                <a:spcPts val="400"/>
+              </a:spcAft>
+              <a:defRPr sz="800" b="0">
+                <a:solidFill>
+                  <a:srgbClr val="FFFFFF"/>
+                </a:solidFill>
+              </a:defRPr>
+            </a:pPr>
+          </a:p>
+          <a:p>
+            <a:pPr>
+              <a:spcAft>
+                <a:spcPts val="400"/>
+              </a:spcAft>
+              <a:defRPr sz="1400" b="0">
+                <a:solidFill>
+                  <a:srgbClr val="FFFFFF"/>
+                </a:solidFill>
+              </a:defRPr>
+            </a:pPr>
+            <a:r>
+              <a:t>Founded by ex-Goldman Sachs (CEO) and ex-Palantir (CTO) executives</a:t>
+            </a:r>
+          </a:p>
+          <a:p>
+            <a:pPr>
+              <a:spcAft>
+                <a:spcPts val="400"/>
+              </a:spcAft>
+              <a:defRPr sz="1400" b="0">
+                <a:solidFill>
+                  <a:srgbClr val="FFFFFF"/>
+                </a:solidFill>
+              </a:defRPr>
+            </a:pPr>
+            <a:r>
+              <a:t>Scaled from $8M → $18M → $31M ARR in 3 years with elite unit economics</a:t>
+            </a:r>
+          </a:p>
+          <a:p>
+            <a:pPr>
+              <a:spcAft>
+                <a:spcPts val="400"/>
+              </a:spcAft>
+              <a:defRPr sz="1400" b="0">
+                <a:solidFill>
+                  <a:srgbClr val="FFFFFF"/>
+                </a:solidFill>
+              </a:defRPr>
+            </a:pPr>
+            <a:r>
+              <a:t>$85M proceeds: European expansion ($34M) + Product dev ($30M) + Headcount ($21M)</a:t>
+            </a:r>
+          </a:p>
+          <a:p>
+            <a:pPr>
+              <a:spcAft>
+                <a:spcPts val="400"/>
+              </a:spcAft>
+              <a:defRPr sz="1400" b="0">
+                <a:solidFill>
+                  <a:srgbClr val="FFFFFF"/>
+                </a:solidFill>
+              </a:defRPr>
+            </a:pPr>
+            <a:r>
+              <a:t>3 LOIs from tier-one European asset managers validate expansion thesis</a:t>
+            </a:r>
+          </a:p>
+          <a:p>
+            <a:pPr>
+              <a:spcAft>
+                <a:spcPts val="400"/>
+              </a:spcAft>
+              <a:defRPr sz="800" b="0">
+                <a:solidFill>
+                  <a:srgbClr val="FFFFFF"/>
+                </a:solidFill>
+              </a:defRPr>
+            </a:pPr>
+          </a:p>
+          <a:p>
+            <a:pPr>
+              <a:spcAft>
+                <a:spcPts val="400"/>
+              </a:spcAft>
+              <a:defRPr sz="1400" b="0">
+                <a:solidFill>
+                  <a:srgbClr val="FF9800"/>
+                </a:solidFill>
+              </a:defRPr>
+            </a:pPr>
+            <a:r>
+              <a:t>Key Risks: Customer concentration (top 3 = 40% ARR), 4-month onboarding cycles, SOC 2 Type II gap</a:t>
+            </a:r>
+          </a:p>
+        </p:txBody>
+      </p:sp>
+    </p:spTree>
+  </p:cSld>
+  <p:clrMapOvr>
+    <a:masterClrMapping/>
+  </p:clrMapOvr>
+</p:sld>
+</file>
+
+<file path=ppt/slides/slide3.xml><?xml version="1.0" encoding="utf-8"?>
+<p:sld xmlns:a="http://schemas.openxmlformats.org/drawingml/2006/main" xmlns:p="http://schemas.openxmlformats.org/presentationml/2006/main" xmlns:r="http://schemas.openxmlformats.org/officeDocument/2006/relationships">
+  <p:cSld>
+    <p:bg>
+      <p:bgPr>
+        <a:solidFill>
+          <a:srgbClr val="0A1F0D"/>
+        </a:solidFill>
+        <a:effectLst/>
+      </p:bgPr>
+    </p:bg>
+    <p:spTree>
+      <p:nvGrpSpPr>
+        <p:cNvPr id="1" name=""/>
+        <p:cNvGrpSpPr/>
+        <p:nvPr/>
+      </p:nvGrpSpPr>
+      <p:grpSpPr/>
+      <p:sp>
+        <p:nvSpPr>
+          <p:cNvPr id="2" name="TextBox 1"/>
+          <p:cNvSpPr txBox="1"/>
+          <p:nvPr/>
+        </p:nvSpPr>
+        <p:spPr>
+          <a:xfrm>
+            <a:off x="731520" y="365760"/>
+            <a:ext cx="10058400" cy="640080"/>
+          </a:xfrm>
+          <a:prstGeom prst="rect">
+            <a:avLst/>
+          </a:prstGeom>
+          <a:noFill/>
+        </p:spPr>
+        <p:txBody>
+          <a:bodyPr wrap="square">
+            <a:spAutoFit/>
+          </a:bodyPr>
+          <a:lstStyle/>
+          <a:p>
+            <a:pPr algn="l">
+              <a:defRPr sz="1400" b="1">
+                <a:solidFill>
+                  <a:srgbClr val="4CAF50"/>
+                </a:solidFill>
+              </a:defRPr>
+            </a:pPr>
+            <a:r>
+              <a:t>INVESTMENT THESIS</a:t>
+            </a:r>
+          </a:p>
+        </p:txBody>
+      </p:sp>
+      <p:sp>
+        <p:nvSpPr>
+          <p:cNvPr id="3" name="TextBox 2"/>
+          <p:cNvSpPr txBox="1"/>
+          <p:nvPr/>
+        </p:nvSpPr>
+        <p:spPr>
+          <a:xfrm>
+            <a:off x="731520" y="1188720"/>
+            <a:ext cx="274320" cy="274320"/>
+          </a:xfrm>
+          <a:prstGeom prst="rect">
+            <a:avLst/>
+          </a:prstGeom>
+          <a:noFill/>
+        </p:spPr>
+        <p:txBody>
+          <a:bodyPr wrap="square">
+            <a:spAutoFit/>
+          </a:bodyPr>
+          <a:lstStyle/>
+          <a:p>
+            <a:pPr algn="ctr">
+              <a:defRPr sz="2000" b="1">
+                <a:solidFill>
+                  <a:srgbClr val="0A1F0D"/>
+                </a:solidFill>
+              </a:defRPr>
+            </a:pPr>
+            <a:r>
+              <a:t>1</a:t>
+            </a:r>
+          </a:p>
+        </p:txBody>
+      </p:sp>
+      <p:sp>
+        <p:nvSpPr>
+          <p:cNvPr id="4" name="TextBox 3"/>
+          <p:cNvSpPr txBox="1"/>
+          <p:nvPr/>
+        </p:nvSpPr>
+        <p:spPr>
+          <a:xfrm>
+            <a:off x="1188720" y="1188720"/>
+            <a:ext cx="9144000" cy="457200"/>
+          </a:xfrm>
+          <a:prstGeom prst="rect">
+            <a:avLst/>
+          </a:prstGeom>
+          <a:noFill/>
+        </p:spPr>
+        <p:txBody>
+          <a:bodyPr wrap="square">
+            <a:spAutoFit/>
+          </a:bodyPr>
+          <a:lstStyle/>
+          <a:p>
+            <a:pPr algn="l">
+              <a:defRPr sz="2000" b="1">
+                <a:solidFill>
+                  <a:srgbClr val="FFFFFF"/>
+                </a:solidFill>
+              </a:defRPr>
+            </a:pPr>
+            <a:r>
+              <a:t>$34B TAM with Regulatory Tailwinds</a:t>
+            </a:r>
+          </a:p>
+        </p:txBody>
+      </p:sp>
+      <p:sp>
+        <p:nvSpPr>
+          <p:cNvPr id="5" name="TextBox 4"/>
+          <p:cNvSpPr txBox="1"/>
+          <p:nvPr/>
+        </p:nvSpPr>
+        <p:spPr>
+          <a:xfrm>
+            <a:off x="1188720" y="1645920"/>
+            <a:ext cx="9144000" cy="1188720"/>
+          </a:xfrm>
+          <a:prstGeom prst="rect">
+            <a:avLst/>
+          </a:prstGeom>
+          <a:noFill/>
+        </p:spPr>
+        <p:txBody>
+          <a:bodyPr wrap="square">
+            <a:spAutoFit/>
+          </a:bodyPr>
+          <a:lstStyle/>
+          <a:p>
+            <a:pPr algn="l">
+              <a:defRPr sz="1300" b="0">
+                <a:solidFill>
+                  <a:srgbClr val="E8F5E9"/>
+                </a:solidFill>
+              </a:defRPr>
+            </a:pPr>
+            <a:r>
+              <a:t>Banks face dual mandate: modernize for AI + comply with DORA/MiFID II/T+1.</a:t>
+            </a:r>
+            <a:br/>
+            <a:r>
+              <a:t>NovaCrest fills gap between rigid legacy (Moody's) and empty platforms (Snowflake).</a:t>
+            </a:r>
+            <a:br/>
+            <a:r>
+              <a:t>Validated by Dr. Sarah Chen, former CDO at EuroBank Corp.</a:t>
+            </a:r>
+          </a:p>
+        </p:txBody>
+      </p:sp>
+      <p:sp>
+        <p:nvSpPr>
+          <p:cNvPr id="6" name="TextBox 5"/>
+          <p:cNvSpPr txBox="1"/>
+          <p:nvPr/>
+        </p:nvSpPr>
+        <p:spPr>
+          <a:xfrm>
+            <a:off x="731520" y="3017520"/>
+            <a:ext cx="274320" cy="274320"/>
+          </a:xfrm>
+          <a:prstGeom prst="rect">
+            <a:avLst/>
+          </a:prstGeom>
+          <a:noFill/>
+        </p:spPr>
+        <p:txBody>
+          <a:bodyPr wrap="square">
+            <a:spAutoFit/>
+          </a:bodyPr>
+          <a:lstStyle/>
+          <a:p>
+            <a:pPr algn="ctr">
+              <a:defRPr sz="2000" b="1">
+                <a:solidFill>
+                  <a:srgbClr val="0A1F0D"/>
+                </a:solidFill>
+              </a:defRPr>
+            </a:pPr>
+            <a:r>
+              <a:t>2</a:t>
+            </a:r>
+          </a:p>
+        </p:txBody>
+      </p:sp>
+      <p:sp>
+        <p:nvSpPr>
+          <p:cNvPr id="7" name="TextBox 6"/>
+          <p:cNvSpPr txBox="1"/>
+          <p:nvPr/>
+        </p:nvSpPr>
+        <p:spPr>
+          <a:xfrm>
+            <a:off x="1188720" y="3017520"/>
+            <a:ext cx="9144000" cy="457200"/>
+          </a:xfrm>
+          <a:prstGeom prst="rect">
+            <a:avLst/>
+          </a:prstGeom>
+          <a:noFill/>
+        </p:spPr>
+        <p:txBody>
+          <a:bodyPr wrap="square">
+            <a:spAutoFit/>
+          </a:bodyPr>
+          <a:lstStyle/>
+          <a:p>
+            <a:pPr algn="l">
+              <a:defRPr sz="2000" b="1">
+                <a:solidFill>
+                  <a:srgbClr val="FFFFFF"/>
+                </a:solidFill>
+              </a:defRPr>
+            </a:pPr>
+            <a:r>
+              <a:t>European Expansion = $40M Catalyst</a:t>
+            </a:r>
+          </a:p>
+        </p:txBody>
+      </p:sp>
+      <p:sp>
+        <p:nvSpPr>
+          <p:cNvPr id="8" name="TextBox 7"/>
+          <p:cNvSpPr txBox="1"/>
+          <p:nvPr/>
+        </p:nvSpPr>
+        <p:spPr>
+          <a:xfrm>
+            <a:off x="1188720" y="3474720"/>
+            <a:ext cx="9144000" cy="1188720"/>
+          </a:xfrm>
+          <a:prstGeom prst="rect">
+            <a:avLst/>
+          </a:prstGeom>
+          <a:noFill/>
+        </p:spPr>
+        <p:txBody>
+          <a:bodyPr wrap="square">
+            <a:spAutoFit/>
+          </a:bodyPr>
+          <a:lstStyle/>
+          <a:p>
+            <a:pPr algn="l">
+              <a:defRPr sz="1300" b="0">
+                <a:solidFill>
+                  <a:srgbClr val="E8F5E9"/>
+                </a:solidFill>
+              </a:defRPr>
+            </a:pPr>
+            <a:r>
+              <a:t>DORA forces EU banks to adopt compliant data infrastructure.</a:t>
+            </a:r>
+            <a:br/>
+            <a:r>
+              <a:t>3 LOIs from tier-one European asset managers.</a:t>
+            </a:r>
+            <a:br/>
+            <a:r>
+              <a:t>London HQ + localized EU data centers planned.</a:t>
+            </a:r>
+          </a:p>
+        </p:txBody>
+      </p:sp>
+      <p:sp>
+        <p:nvSpPr>
+          <p:cNvPr id="9" name="TextBox 8"/>
+          <p:cNvSpPr txBox="1"/>
+          <p:nvPr/>
+        </p:nvSpPr>
+        <p:spPr>
+          <a:xfrm>
+            <a:off x="731520" y="4846320"/>
+            <a:ext cx="274320" cy="274320"/>
+          </a:xfrm>
+          <a:prstGeom prst="rect">
+            <a:avLst/>
+          </a:prstGeom>
+          <a:noFill/>
+        </p:spPr>
+        <p:txBody>
+          <a:bodyPr wrap="square">
+            <a:spAutoFit/>
+          </a:bodyPr>
+          <a:lstStyle/>
+          <a:p>
+            <a:pPr algn="ctr">
+              <a:defRPr sz="2000" b="1">
+                <a:solidFill>
+                  <a:srgbClr val="0A1F0D"/>
+                </a:solidFill>
+              </a:defRPr>
+            </a:pPr>
+            <a:r>
+              <a:t>3</a:t>
+            </a:r>
+          </a:p>
+        </p:txBody>
+      </p:sp>
+      <p:sp>
+        <p:nvSpPr>
+          <p:cNvPr id="10" name="TextBox 9"/>
+          <p:cNvSpPr txBox="1"/>
+          <p:nvPr/>
+        </p:nvSpPr>
+        <p:spPr>
+          <a:xfrm>
+            <a:off x="1188720" y="4846320"/>
+            <a:ext cx="9144000" cy="457200"/>
+          </a:xfrm>
+          <a:prstGeom prst="rect">
+            <a:avLst/>
+          </a:prstGeom>
+          <a:noFill/>
+        </p:spPr>
+        <p:txBody>
+          <a:bodyPr wrap="square">
+            <a:spAutoFit/>
+          </a:bodyPr>
+          <a:lstStyle/>
+          <a:p>
+            <a:pPr algn="l">
+              <a:defRPr sz="2000" b="1">
+                <a:solidFill>
+                  <a:srgbClr val="FFFFFF"/>
+                </a:solidFill>
+              </a:defRPr>
+            </a:pPr>
+            <a:r>
+              <a:t>Elite Land-and-Expand Economics</a:t>
+            </a:r>
+          </a:p>
+        </p:txBody>
+      </p:sp>
+      <p:sp>
+        <p:nvSpPr>
+          <p:cNvPr id="11" name="TextBox 10"/>
+          <p:cNvSpPr txBox="1"/>
+          <p:nvPr/>
+        </p:nvSpPr>
+        <p:spPr>
+          <a:xfrm>
+            <a:off x="1188720" y="5303520"/>
+            <a:ext cx="9144000" cy="1188720"/>
+          </a:xfrm>
+          <a:prstGeom prst="rect">
+            <a:avLst/>
+          </a:prstGeom>
+          <a:noFill/>
+        </p:spPr>
+        <p:txBody>
+          <a:bodyPr wrap="square">
+            <a:spAutoFit/>
+          </a:bodyPr>
+          <a:lstStyle/>
+          <a:p>
+            <a:pPr algn="l">
+              <a:defRPr sz="1300" b="0">
+                <a:solidFill>
+                  <a:srgbClr val="E8F5E9"/>
+                </a:solidFill>
+              </a:defRPr>
+            </a:pPr>
+            <a:r>
+              <a:t>Land at $180K ACV (DataBridge) → expand to $500K+ (RiskLens + ComplianceSync).</a:t>
+            </a:r>
+            <a:br/>
+            <a:r>
+              <a:t>Drives 135% NRR within 12-18 months.</a:t>
+            </a:r>
+            <a:br/>
+            <a:r>
+              <a:t>Avalon AM: 70% reduction in reconciliation time, $2M/yr savings.</a:t>
+            </a:r>
+          </a:p>
+        </p:txBody>
+      </p:sp>
+    </p:spTree>
+  </p:cSld>
+  <p:clrMapOvr>
+    <a:masterClrMapping/>
+  </p:clrMapOvr>
+</p:sld>
+</file>
+
+<file path=ppt/slides/slide4.xml><?xml version="1.0" encoding="utf-8"?>
+<p:sld xmlns:a="http://schemas.openxmlformats.org/drawingml/2006/main" xmlns:p="http://schemas.openxmlformats.org/presentationml/2006/main" xmlns:r="http://schemas.openxmlformats.org/officeDocument/2006/relationships">
+  <p:cSld>
+    <p:bg>
+      <p:bgPr>
+        <a:solidFill>
+          <a:srgbClr val="0A1F0D"/>
+        </a:solidFill>
+        <a:effectLst/>
+      </p:bgPr>
+    </p:bg>
+    <p:spTree>
+      <p:nvGrpSpPr>
+        <p:cNvPr id="1" name=""/>
+        <p:cNvGrpSpPr/>
+        <p:nvPr/>
+      </p:nvGrpSpPr>
+      <p:grpSpPr/>
+      <p:sp>
+        <p:nvSpPr>
+          <p:cNvPr id="2" name="TextBox 1"/>
+          <p:cNvSpPr txBox="1"/>
+          <p:nvPr/>
+        </p:nvSpPr>
+        <p:spPr>
+          <a:xfrm>
+            <a:off x="731520" y="365760"/>
+            <a:ext cx="10058400" cy="640080"/>
+          </a:xfrm>
+          <a:prstGeom prst="rect">
+            <a:avLst/>
+          </a:prstGeom>
+          <a:noFill/>
+        </p:spPr>
+        <p:txBody>
+          <a:bodyPr wrap="square">
+            <a:spAutoFit/>
+          </a:bodyPr>
+          <a:lstStyle/>
+          <a:p>
+            <a:pPr algn="l">
+              <a:defRPr sz="1400" b="1">
+                <a:solidFill>
+                  <a:srgbClr val="4CAF50"/>
+                </a:solidFill>
+              </a:defRPr>
+            </a:pPr>
+            <a:r>
+              <a:t>FINANCIAL PERFORMANCE</a:t>
+            </a:r>
+          </a:p>
+        </p:txBody>
+      </p:sp>
+      <p:sp>
+        <p:nvSpPr>
+          <p:cNvPr id="3" name="TextBox 2"/>
+          <p:cNvSpPr txBox="1"/>
+          <p:nvPr/>
+        </p:nvSpPr>
+        <p:spPr>
+          <a:xfrm>
+            <a:off x="731520" y="1097280"/>
+            <a:ext cx="5029200" cy="457200"/>
+          </a:xfrm>
+          <a:prstGeom prst="rect">
+            <a:avLst/>
+          </a:prstGeom>
+          <a:noFill/>
+        </p:spPr>
+        <p:txBody>
+          <a:bodyPr wrap="square">
+            <a:spAutoFit/>
+          </a:bodyPr>
+          <a:lstStyle/>
+          <a:p>
+            <a:pPr algn="l">
+              <a:defRPr sz="2000" b="1">
+                <a:solidFill>
+                  <a:srgbClr val="FFFFFF"/>
+                </a:solidFill>
+              </a:defRPr>
+            </a:pPr>
+            <a:r>
+              <a:t>ARR Growth Trajectory</a:t>
+            </a:r>
+          </a:p>
+        </p:txBody>
+      </p:sp>
+      <p:sp>
+        <p:nvSpPr>
+          <p:cNvPr id="4" name="TextBox 3"/>
+          <p:cNvSpPr txBox="1"/>
+          <p:nvPr/>
+        </p:nvSpPr>
+        <p:spPr>
+          <a:xfrm>
+            <a:off x="731520" y="1828800"/>
+            <a:ext cx="914400" cy="457200"/>
+          </a:xfrm>
+          <a:prstGeom prst="rect">
+            <a:avLst/>
+          </a:prstGeom>
+          <a:noFill/>
+        </p:spPr>
+        <p:txBody>
+          <a:bodyPr wrap="square">
+            <a:spAutoFit/>
+          </a:bodyPr>
+          <a:lstStyle/>
+          <a:p>
+            <a:pPr algn="l">
+              <a:defRPr sz="1400" b="0">
+                <a:solidFill>
+                  <a:srgbClr val="999999"/>
+                </a:solidFill>
+              </a:defRPr>
+            </a:pPr>
+            <a:r>
+              <a:t>2023</a:t>
+            </a:r>
+          </a:p>
+        </p:txBody>
+      </p:sp>
+      <p:sp>
+        <p:nvSpPr>
+          <p:cNvPr id="5" name="Rectangle 4"/>
+          <p:cNvSpPr/>
+          <p:nvPr/>
+        </p:nvSpPr>
+        <p:spPr>
+          <a:xfrm>
+            <a:off x="1645920" y="1874520"/>
+            <a:ext cx="1097280" cy="365760"/>
+          </a:xfrm>
+          <a:prstGeom prst="rect">
+            <a:avLst/>
+          </a:prstGeom>
+          <a:solidFill>
+            <a:srgbClr val="4CAF50"/>
+          </a:solidFill>
+          <a:ln>
+            <a:noFill/>
+          </a:ln>
+        </p:spPr>
+        <p:style>
+          <a:lnRef idx="1">
+            <a:schemeClr val="accent1"/>
+          </a:lnRef>
+          <a:fillRef idx="3">
+            <a:schemeClr val="accent1"/>
+          </a:fillRef>
+          <a:effectRef idx="2">
+            <a:schemeClr val="accent1"/>
+          </a:effectRef>
+          <a:fontRef idx="minor">
+            <a:schemeClr val="lt1"/>
+          </a:fontRef>
+        </p:style>
+        <p:txBody>
+          <a:bodyPr rtlCol="0" anchor="ctr"/>
+          <a:lstStyle/>
+          <a:p>
+            <a:pPr algn="ctr"/>
+          </a:p>
+        </p:txBody>
+      </p:sp>
+      <p:sp>
+        <p:nvSpPr>
+          <p:cNvPr id="6" name="TextBox 5"/>
+          <p:cNvSpPr txBox="1"/>
+          <p:nvPr/>
+        </p:nvSpPr>
+        <p:spPr>
+          <a:xfrm>
+            <a:off x="2834640" y="1828800"/>
+            <a:ext cx="1371600" cy="457200"/>
+          </a:xfrm>
+          <a:prstGeom prst="rect">
+            <a:avLst/>
+          </a:prstGeom>
+          <a:noFill/>
+        </p:spPr>
+        <p:txBody>
+          <a:bodyPr wrap="square">
+            <a:spAutoFit/>
+          </a:bodyPr>
+          <a:lstStyle/>
+          <a:p>
+            <a:pPr algn="l">
+              <a:defRPr sz="1600" b="1">
+                <a:solidFill>
+                  <a:srgbClr val="FFFFFF"/>
+                </a:solidFill>
+              </a:defRPr>
+            </a:pPr>
+            <a:r>
+              <a:t>$8.0M</a:t>
+            </a:r>
+          </a:p>
+        </p:txBody>
+      </p:sp>
+      <p:sp>
+        <p:nvSpPr>
+          <p:cNvPr id="7" name="TextBox 6"/>
+          <p:cNvSpPr txBox="1"/>
+          <p:nvPr/>
+        </p:nvSpPr>
+        <p:spPr>
+          <a:xfrm>
+            <a:off x="731520" y="2651760"/>
+            <a:ext cx="914400" cy="457200"/>
+          </a:xfrm>
+          <a:prstGeom prst="rect">
+            <a:avLst/>
+          </a:prstGeom>
+          <a:noFill/>
+        </p:spPr>
+        <p:txBody>
+          <a:bodyPr wrap="square">
+            <a:spAutoFit/>
+          </a:bodyPr>
+          <a:lstStyle/>
+          <a:p>
+            <a:pPr algn="l">
+              <a:defRPr sz="1400" b="0">
+                <a:solidFill>
+                  <a:srgbClr val="999999"/>
+                </a:solidFill>
+              </a:defRPr>
+            </a:pPr>
+            <a:r>
+              <a:t>2024</a:t>
+            </a:r>
+          </a:p>
+        </p:txBody>
+      </p:sp>
+      <p:sp>
+        <p:nvSpPr>
+          <p:cNvPr id="8" name="Rectangle 7"/>
+          <p:cNvSpPr/>
+          <p:nvPr/>
+        </p:nvSpPr>
+        <p:spPr>
+          <a:xfrm>
+            <a:off x="1645920" y="2697480"/>
+            <a:ext cx="2468880" cy="365760"/>
+          </a:xfrm>
+          <a:prstGeom prst="rect">
+            <a:avLst/>
+          </a:prstGeom>
+          <a:solidFill>
+            <a:srgbClr val="4CAF50"/>
+          </a:solidFill>
+          <a:ln>
+            <a:noFill/>
+          </a:ln>
+        </p:spPr>
+        <p:style>
+          <a:lnRef idx="1">
+            <a:schemeClr val="accent1"/>
+          </a:lnRef>
+          <a:fillRef idx="3">
+            <a:schemeClr val="accent1"/>
+          </a:fillRef>
+          <a:effectRef idx="2">
+            <a:schemeClr val="accent1"/>
+          </a:effectRef>
+          <a:fontRef idx="minor">
+            <a:schemeClr val="lt1"/>
+          </a:fontRef>
+        </p:style>
+        <p:txBody>
+          <a:bodyPr rtlCol="0" anchor="ctr"/>
+          <a:lstStyle/>
+          <a:p>
+            <a:pPr algn="ctr"/>
+          </a:p>
+        </p:txBody>
+      </p:sp>
+      <p:sp>
+        <p:nvSpPr>
+          <p:cNvPr id="9" name="TextBox 8"/>
+          <p:cNvSpPr txBox="1"/>
+          <p:nvPr/>
+        </p:nvSpPr>
+        <p:spPr>
+          <a:xfrm>
+            <a:off x="4206240" y="2651760"/>
+            <a:ext cx="1371600" cy="457200"/>
+          </a:xfrm>
+          <a:prstGeom prst="rect">
+            <a:avLst/>
+          </a:prstGeom>
+          <a:noFill/>
+        </p:spPr>
+        <p:txBody>
+          <a:bodyPr wrap="square">
+            <a:spAutoFit/>
+          </a:bodyPr>
+          <a:lstStyle/>
+          <a:p>
+            <a:pPr algn="l">
+              <a:defRPr sz="1600" b="1">
+                <a:solidFill>
+                  <a:srgbClr val="FFFFFF"/>
+                </a:solidFill>
+              </a:defRPr>
+            </a:pPr>
+            <a:r>
+              <a:t>$18.0M</a:t>
+            </a:r>
+          </a:p>
+        </p:txBody>
+      </p:sp>
+      <p:sp>
+        <p:nvSpPr>
+          <p:cNvPr id="10" name="TextBox 9"/>
+          <p:cNvSpPr txBox="1"/>
+          <p:nvPr/>
+        </p:nvSpPr>
+        <p:spPr>
+          <a:xfrm>
+            <a:off x="731520" y="3474720"/>
+            <a:ext cx="914400" cy="457200"/>
+          </a:xfrm>
+          <a:prstGeom prst="rect">
+            <a:avLst/>
+          </a:prstGeom>
+          <a:noFill/>
+        </p:spPr>
+        <p:txBody>
+          <a:bodyPr wrap="square">
+            <a:spAutoFit/>
+          </a:bodyPr>
+          <a:lstStyle/>
+          <a:p>
+            <a:pPr algn="l">
+              <a:defRPr sz="1400" b="0">
+                <a:solidFill>
+                  <a:srgbClr val="999999"/>
+                </a:solidFill>
+              </a:defRPr>
+            </a:pPr>
+            <a:r>
+              <a:t>2025</a:t>
+            </a:r>
+          </a:p>
+        </p:txBody>
+      </p:sp>
+      <p:sp>
+        <p:nvSpPr>
+          <p:cNvPr id="11" name="Rectangle 10"/>
+          <p:cNvSpPr/>
+          <p:nvPr/>
+        </p:nvSpPr>
+        <p:spPr>
+          <a:xfrm>
+            <a:off x="1645920" y="3520440"/>
+            <a:ext cx="4206240" cy="365760"/>
+          </a:xfrm>
+          <a:prstGeom prst="rect">
+            <a:avLst/>
+          </a:prstGeom>
+          <a:solidFill>
+            <a:srgbClr val="4CAF50"/>
+          </a:solidFill>
+          <a:ln>
+            <a:noFill/>
+          </a:ln>
+        </p:spPr>
+        <p:style>
+          <a:lnRef idx="1">
+            <a:schemeClr val="accent1"/>
+          </a:lnRef>
+          <a:fillRef idx="3">
+            <a:schemeClr val="accent1"/>
+          </a:fillRef>
+          <a:effectRef idx="2">
+            <a:schemeClr val="accent1"/>
+          </a:effectRef>
+          <a:fontRef idx="minor">
+            <a:schemeClr val="lt1"/>
+          </a:fontRef>
+        </p:style>
+        <p:txBody>
+          <a:bodyPr rtlCol="0" anchor="ctr"/>
+          <a:lstStyle/>
+          <a:p>
+            <a:pPr algn="ctr"/>
+          </a:p>
+        </p:txBody>
+      </p:sp>
+      <p:sp>
+        <p:nvSpPr>
+          <p:cNvPr id="12" name="TextBox 11"/>
+          <p:cNvSpPr txBox="1"/>
+          <p:nvPr/>
+        </p:nvSpPr>
+        <p:spPr>
+          <a:xfrm>
+            <a:off x="5943599" y="3474720"/>
+            <a:ext cx="1371600" cy="457200"/>
+          </a:xfrm>
+          <a:prstGeom prst="rect">
+            <a:avLst/>
+          </a:prstGeom>
+          <a:noFill/>
+        </p:spPr>
+        <p:txBody>
+          <a:bodyPr wrap="square">
+            <a:spAutoFit/>
+          </a:bodyPr>
+          <a:lstStyle/>
+          <a:p>
+            <a:pPr algn="l">
+              <a:defRPr sz="1600" b="1">
+                <a:solidFill>
+                  <a:srgbClr val="FFFFFF"/>
+                </a:solidFill>
+              </a:defRPr>
+            </a:pPr>
+            <a:r>
+              <a:t>$31.0M</a:t>
+            </a:r>
+          </a:p>
+        </p:txBody>
+      </p:sp>
+      <p:sp>
+        <p:nvSpPr>
+          <p:cNvPr id="13" name="TextBox 12"/>
+          <p:cNvSpPr txBox="1"/>
+          <p:nvPr/>
+        </p:nvSpPr>
+        <p:spPr>
+          <a:xfrm>
+            <a:off x="731520" y="4572000"/>
+            <a:ext cx="4572000" cy="457200"/>
+          </a:xfrm>
+          <a:prstGeom prst="rect">
+            <a:avLst/>
+          </a:prstGeom>
+          <a:noFill/>
+        </p:spPr>
+        <p:txBody>
+          <a:bodyPr wrap="square">
+            <a:spAutoFit/>
+          </a:bodyPr>
+          <a:lstStyle/>
+          <a:p>
+            <a:pPr algn="l">
+              <a:defRPr sz="1300" b="0">
+                <a:solidFill>
+                  <a:srgbClr val="999999"/>
+                </a:solidFill>
+              </a:defRPr>
+            </a:pPr>
+            <a:r>
+              <a:t>125% → 72% YoY Growth  |  78% Gross Margins</a:t>
+            </a:r>
+          </a:p>
+        </p:txBody>
+      </p:sp>
+      <p:sp>
+        <p:nvSpPr>
+          <p:cNvPr id="14" name="TextBox 13"/>
+          <p:cNvSpPr txBox="1"/>
+          <p:nvPr/>
+        </p:nvSpPr>
+        <p:spPr>
+          <a:xfrm>
+            <a:off x="6400800" y="1097280"/>
+            <a:ext cx="5029200" cy="457200"/>
+          </a:xfrm>
+          <a:prstGeom prst="rect">
+            <a:avLst/>
+          </a:prstGeom>
+          <a:noFill/>
+        </p:spPr>
+        <p:txBody>
+          <a:bodyPr wrap="square">
+            <a:spAutoFit/>
+          </a:bodyPr>
+          <a:lstStyle/>
+          <a:p>
+            <a:pPr algn="l">
+              <a:defRPr sz="2000" b="1">
+                <a:solidFill>
+                  <a:srgbClr val="FFFFFF"/>
+                </a:solidFill>
+              </a:defRPr>
+            </a:pPr>
+            <a:r>
+              <a:t>Unit Economics</a:t>
+            </a:r>
+          </a:p>
+        </p:txBody>
+      </p:sp>
+      <p:sp>
+        <p:nvSpPr>
+          <p:cNvPr id="15" name="TextBox 14"/>
+          <p:cNvSpPr txBox="1"/>
+          <p:nvPr/>
+        </p:nvSpPr>
+        <p:spPr>
+          <a:xfrm>
+            <a:off x="6400800" y="1828800"/>
+            <a:ext cx="3200400" cy="457200"/>
+          </a:xfrm>
+          <a:prstGeom prst="rect">
+            <a:avLst/>
+          </a:prstGeom>
+          <a:noFill/>
+        </p:spPr>
+        <p:txBody>
+          <a:bodyPr wrap="square">
+            <a:spAutoFit/>
+          </a:bodyPr>
+          <a:lstStyle/>
+          <a:p>
+            <a:pPr algn="l">
+              <a:defRPr sz="1400" b="0">
+                <a:solidFill>
+                  <a:srgbClr val="E8F5E9"/>
+                </a:solidFill>
+              </a:defRPr>
+            </a:pPr>
+            <a:r>
+              <a:t>Net Retention Rate</a:t>
+            </a:r>
+          </a:p>
+        </p:txBody>
+      </p:sp>
+      <p:sp>
+        <p:nvSpPr>
+          <p:cNvPr id="16" name="TextBox 15"/>
+          <p:cNvSpPr txBox="1"/>
+          <p:nvPr/>
+        </p:nvSpPr>
+        <p:spPr>
+          <a:xfrm>
+            <a:off x="9601200" y="1828800"/>
+            <a:ext cx="1828800" cy="457200"/>
+          </a:xfrm>
+          <a:prstGeom prst="rect">
+            <a:avLst/>
+          </a:prstGeom>
+          <a:noFill/>
+        </p:spPr>
+        <p:txBody>
+          <a:bodyPr wrap="square">
+            <a:spAutoFit/>
+          </a:bodyPr>
+          <a:lstStyle/>
+          <a:p>
+            <a:pPr algn="r">
+              <a:defRPr sz="1600" b="1">
+                <a:solidFill>
+                  <a:srgbClr val="4CAF50"/>
+                </a:solidFill>
+              </a:defRPr>
+            </a:pPr>
+            <a:r>
+              <a:t>135%</a:t>
+            </a:r>
+          </a:p>
+        </p:txBody>
+      </p:sp>
+      <p:sp>
+        <p:nvSpPr>
+          <p:cNvPr id="17" name="TextBox 16"/>
+          <p:cNvSpPr txBox="1"/>
+          <p:nvPr/>
+        </p:nvSpPr>
+        <p:spPr>
+          <a:xfrm>
+            <a:off x="6400800" y="2468880"/>
+            <a:ext cx="3200400" cy="457200"/>
+          </a:xfrm>
+          <a:prstGeom prst="rect">
+            <a:avLst/>
+          </a:prstGeom>
+          <a:noFill/>
+        </p:spPr>
+        <p:txBody>
+          <a:bodyPr wrap="square">
+            <a:spAutoFit/>
+          </a:bodyPr>
+          <a:lstStyle/>
+          <a:p>
+            <a:pPr algn="l">
+              <a:defRPr sz="1400" b="0">
+                <a:solidFill>
+                  <a:srgbClr val="E8F5E9"/>
+                </a:solidFill>
+              </a:defRPr>
+            </a:pPr>
+            <a:r>
+              <a:t>CAC Payback</a:t>
+            </a:r>
+          </a:p>
+        </p:txBody>
+      </p:sp>
+      <p:sp>
+        <p:nvSpPr>
+          <p:cNvPr id="18" name="TextBox 17"/>
+          <p:cNvSpPr txBox="1"/>
+          <p:nvPr/>
+        </p:nvSpPr>
+        <p:spPr>
+          <a:xfrm>
+            <a:off x="9601200" y="2468880"/>
+            <a:ext cx="1828800" cy="457200"/>
+          </a:xfrm>
+          <a:prstGeom prst="rect">
+            <a:avLst/>
+          </a:prstGeom>
+          <a:noFill/>
+        </p:spPr>
+        <p:txBody>
+          <a:bodyPr wrap="square">
+            <a:spAutoFit/>
+          </a:bodyPr>
+          <a:lstStyle/>
+          <a:p>
+            <a:pPr algn="r">
+              <a:defRPr sz="1600" b="1">
+                <a:solidFill>
+                  <a:srgbClr val="4CAF50"/>
+                </a:solidFill>
+              </a:defRPr>
+            </a:pPr>
+            <a:r>
+              <a:t>14 months</a:t>
+            </a:r>
+          </a:p>
+        </p:txBody>
+      </p:sp>
+      <p:sp>
+        <p:nvSpPr>
+          <p:cNvPr id="19" name="TextBox 18"/>
+          <p:cNvSpPr txBox="1"/>
+          <p:nvPr/>
+        </p:nvSpPr>
+        <p:spPr>
+          <a:xfrm>
+            <a:off x="6400800" y="3108960"/>
+            <a:ext cx="3200400" cy="457200"/>
+          </a:xfrm>
+          <a:prstGeom prst="rect">
+            <a:avLst/>
+          </a:prstGeom>
+          <a:noFill/>
+        </p:spPr>
+        <p:txBody>
+          <a:bodyPr wrap="square">
+            <a:spAutoFit/>
+          </a:bodyPr>
+          <a:lstStyle/>
+          <a:p>
+            <a:pPr algn="l">
+              <a:defRPr sz="1400" b="0">
+                <a:solidFill>
+                  <a:srgbClr val="E8F5E9"/>
+                </a:solidFill>
+              </a:defRPr>
+            </a:pPr>
+            <a:r>
+              <a:t>Rule of 40 Score</a:t>
+            </a:r>
+          </a:p>
+        </p:txBody>
+      </p:sp>
+      <p:sp>
+        <p:nvSpPr>
+          <p:cNvPr id="20" name="TextBox 19"/>
+          <p:cNvSpPr txBox="1"/>
+          <p:nvPr/>
+        </p:nvSpPr>
+        <p:spPr>
+          <a:xfrm>
+            <a:off x="9601200" y="3108960"/>
+            <a:ext cx="1828800" cy="457200"/>
+          </a:xfrm>
+          <a:prstGeom prst="rect">
+            <a:avLst/>
+          </a:prstGeom>
+          <a:noFill/>
+        </p:spPr>
+        <p:txBody>
+          <a:bodyPr wrap="square">
+            <a:spAutoFit/>
+          </a:bodyPr>
+          <a:lstStyle/>
+          <a:p>
+            <a:pPr algn="r">
+              <a:defRPr sz="1600" b="1">
+                <a:solidFill>
+                  <a:srgbClr val="4CAF50"/>
+                </a:solidFill>
+              </a:defRPr>
+            </a:pPr>
+            <a:r>
+              <a:t>54</a:t>
+            </a:r>
+          </a:p>
+        </p:txBody>
+      </p:sp>
+      <p:sp>
+        <p:nvSpPr>
+          <p:cNvPr id="21" name="TextBox 20"/>
+          <p:cNvSpPr txBox="1"/>
+          <p:nvPr/>
+        </p:nvSpPr>
+        <p:spPr>
+          <a:xfrm>
+            <a:off x="6400800" y="3749039"/>
+            <a:ext cx="3200400" cy="457200"/>
+          </a:xfrm>
+          <a:prstGeom prst="rect">
+            <a:avLst/>
+          </a:prstGeom>
+          <a:noFill/>
+        </p:spPr>
+        <p:txBody>
+          <a:bodyPr wrap="square">
+            <a:spAutoFit/>
+          </a:bodyPr>
+          <a:lstStyle/>
+          <a:p>
+            <a:pPr algn="l">
+              <a:defRPr sz="1400" b="0">
+                <a:solidFill>
+                  <a:srgbClr val="E8F5E9"/>
+                </a:solidFill>
+              </a:defRPr>
+            </a:pPr>
+            <a:r>
+              <a:t>Avg Landing ACV</a:t>
+            </a:r>
+          </a:p>
+        </p:txBody>
+      </p:sp>
+      <p:sp>
+        <p:nvSpPr>
+          <p:cNvPr id="22" name="TextBox 21"/>
+          <p:cNvSpPr txBox="1"/>
+          <p:nvPr/>
+        </p:nvSpPr>
+        <p:spPr>
+          <a:xfrm>
+            <a:off x="9601200" y="3749039"/>
+            <a:ext cx="1828800" cy="457200"/>
+          </a:xfrm>
+          <a:prstGeom prst="rect">
+            <a:avLst/>
+          </a:prstGeom>
+          <a:noFill/>
+        </p:spPr>
+        <p:txBody>
+          <a:bodyPr wrap="square">
+            <a:spAutoFit/>
+          </a:bodyPr>
+          <a:lstStyle/>
+          <a:p>
+            <a:pPr algn="r">
+              <a:defRPr sz="1600" b="1">
+                <a:solidFill>
+                  <a:srgbClr val="4CAF50"/>
+                </a:solidFill>
+              </a:defRPr>
+            </a:pPr>
+            <a:r>
+              <a:t>$180K</a:t>
+            </a:r>
+          </a:p>
+        </p:txBody>
+      </p:sp>
+      <p:sp>
+        <p:nvSpPr>
+          <p:cNvPr id="23" name="TextBox 22"/>
+          <p:cNvSpPr txBox="1"/>
+          <p:nvPr/>
+        </p:nvSpPr>
+        <p:spPr>
+          <a:xfrm>
+            <a:off x="6400800" y="4389120"/>
+            <a:ext cx="3200400" cy="457200"/>
+          </a:xfrm>
+          <a:prstGeom prst="rect">
+            <a:avLst/>
+          </a:prstGeom>
+          <a:noFill/>
+        </p:spPr>
+        <p:txBody>
+          <a:bodyPr wrap="square">
+            <a:spAutoFit/>
+          </a:bodyPr>
+          <a:lstStyle/>
+          <a:p>
+            <a:pPr algn="l">
+              <a:defRPr sz="1400" b="0">
+                <a:solidFill>
+                  <a:srgbClr val="E8F5E9"/>
+                </a:solidFill>
+              </a:defRPr>
+            </a:pPr>
+            <a:r>
+              <a:t>Expanded ACV</a:t>
+            </a:r>
+          </a:p>
+        </p:txBody>
+      </p:sp>
+      <p:sp>
+        <p:nvSpPr>
+          <p:cNvPr id="24" name="TextBox 23"/>
+          <p:cNvSpPr txBox="1"/>
+          <p:nvPr/>
+        </p:nvSpPr>
+        <p:spPr>
+          <a:xfrm>
+            <a:off x="9601200" y="4389120"/>
+            <a:ext cx="1828800" cy="457200"/>
+          </a:xfrm>
+          <a:prstGeom prst="rect">
+            <a:avLst/>
+          </a:prstGeom>
+          <a:noFill/>
+        </p:spPr>
+        <p:txBody>
+          <a:bodyPr wrap="square">
+            <a:spAutoFit/>
+          </a:bodyPr>
+          <a:lstStyle/>
+          <a:p>
+            <a:pPr algn="r">
+              <a:defRPr sz="1600" b="1">
+                <a:solidFill>
+                  <a:srgbClr val="4CAF50"/>
+                </a:solidFill>
+              </a:defRPr>
+            </a:pPr>
+            <a:r>
+              <a:t>$500K+</a:t>
+            </a:r>
+          </a:p>
+        </p:txBody>
+      </p:sp>
+      <p:sp>
+        <p:nvSpPr>
+          <p:cNvPr id="25" name="TextBox 24"/>
+          <p:cNvSpPr txBox="1"/>
+          <p:nvPr/>
+        </p:nvSpPr>
+        <p:spPr>
+          <a:xfrm>
+            <a:off x="6400800" y="5029200"/>
+            <a:ext cx="3200400" cy="457200"/>
+          </a:xfrm>
+          <a:prstGeom prst="rect">
+            <a:avLst/>
+          </a:prstGeom>
+          <a:noFill/>
+        </p:spPr>
+        <p:txBody>
+          <a:bodyPr wrap="square">
+            <a:spAutoFit/>
+          </a:bodyPr>
+          <a:lstStyle/>
+          <a:p>
+            <a:pPr algn="l">
+              <a:defRPr sz="1400" b="0">
+                <a:solidFill>
+                  <a:srgbClr val="E8F5E9"/>
+                </a:solidFill>
+              </a:defRPr>
+            </a:pPr>
+            <a:r>
+              <a:t>Valuation (ARR multiple)</a:t>
+            </a:r>
+          </a:p>
+        </p:txBody>
+      </p:sp>
+      <p:sp>
+        <p:nvSpPr>
+          <p:cNvPr id="26" name="TextBox 25"/>
+          <p:cNvSpPr txBox="1"/>
+          <p:nvPr/>
+        </p:nvSpPr>
+        <p:spPr>
+          <a:xfrm>
+            <a:off x="9601200" y="5029200"/>
+            <a:ext cx="1828800" cy="457200"/>
+          </a:xfrm>
+          <a:prstGeom prst="rect">
+            <a:avLst/>
+          </a:prstGeom>
+          <a:noFill/>
+        </p:spPr>
+        <p:txBody>
+          <a:bodyPr wrap="square">
+            <a:spAutoFit/>
+          </a:bodyPr>
+          <a:lstStyle/>
+          <a:p>
+            <a:pPr algn="r">
+              <a:defRPr sz="1600" b="1">
+                <a:solidFill>
+                  <a:srgbClr val="4CAF50"/>
+                </a:solidFill>
+              </a:defRPr>
+            </a:pPr>
+            <a:r>
+              <a:t>~9.1x</a:t>
+            </a:r>
+          </a:p>
+        </p:txBody>
+      </p:sp>
+    </p:spTree>
+  </p:cSld>
+  <p:clrMapOvr>
+    <a:masterClrMapping/>
+  </p:clrMapOvr>
+</p:sld>
+</file>
+
+<file path=ppt/slides/slide5.xml><?xml version="1.0" encoding="utf-8"?>
+<p:sld xmlns:a="http://schemas.openxmlformats.org/drawingml/2006/main" xmlns:p="http://schemas.openxmlformats.org/presentationml/2006/main" xmlns:r="http://schemas.openxmlformats.org/officeDocument/2006/relationships">
+  <p:cSld>
+    <p:bg>
+      <p:bgPr>
+        <a:solidFill>
+          <a:srgbClr val="0A1F0D"/>
+        </a:solidFill>
+        <a:effectLst/>
+      </p:bgPr>
+    </p:bg>
+    <p:spTree>
+      <p:nvGrpSpPr>
+        <p:cNvPr id="1" name=""/>
+        <p:cNvGrpSpPr/>
+        <p:nvPr/>
+      </p:nvGrpSpPr>
+      <p:grpSpPr/>
+      <p:sp>
+        <p:nvSpPr>
+          <p:cNvPr id="2" name="TextBox 1"/>
+          <p:cNvSpPr txBox="1"/>
+          <p:nvPr/>
+        </p:nvSpPr>
+        <p:spPr>
+          <a:xfrm>
+            <a:off x="731520" y="365760"/>
+            <a:ext cx="10058400" cy="640080"/>
+          </a:xfrm>
+          <a:prstGeom prst="rect">
+            <a:avLst/>
+          </a:prstGeom>
+          <a:noFill/>
+        </p:spPr>
+        <p:txBody>
+          <a:bodyPr wrap="square">
+            <a:spAutoFit/>
+          </a:bodyPr>
+          <a:lstStyle/>
+          <a:p>
+            <a:pPr algn="l">
+              <a:defRPr sz="1400" b="1">
+                <a:solidFill>
+                  <a:srgbClr val="4CAF50"/>
+                </a:solidFill>
+              </a:defRPr>
+            </a:pPr>
+            <a:r>
+              <a:t>DEAL STRUCTURE &amp; USE OF PROCEEDS</a:t>
+            </a:r>
+          </a:p>
+        </p:txBody>
+      </p:sp>
+      <p:sp>
+        <p:nvSpPr>
+          <p:cNvPr id="3" name="TextBox 2"/>
+          <p:cNvSpPr txBox="1"/>
+          <p:nvPr/>
+        </p:nvSpPr>
+        <p:spPr>
+          <a:xfrm>
+            <a:off x="731520" y="1097280"/>
+            <a:ext cx="5029200" cy="2743200"/>
+          </a:xfrm>
+          <a:prstGeom prst="rect">
+            <a:avLst/>
+          </a:prstGeom>
+          <a:noFill/>
+        </p:spPr>
+        <p:txBody>
+          <a:bodyPr wrap="square">
+            <a:spAutoFit/>
+          </a:bodyPr>
+          <a:lstStyle/>
+          <a:p>
+            <a:pPr>
+              <a:spcAft>
+                <a:spcPts val="400"/>
+              </a:spcAft>
+              <a:defRPr sz="2000" b="1">
+                <a:solidFill>
+                  <a:srgbClr val="FFFFFF"/>
+                </a:solidFill>
+              </a:defRPr>
+            </a:pPr>
+            <a:r>
+              <a:t>Transaction Overview</a:t>
+            </a:r>
+          </a:p>
+          <a:p>
+            <a:pPr>
+              <a:spcAft>
+                <a:spcPts val="400"/>
+              </a:spcAft>
+              <a:defRPr sz="600" b="0">
+                <a:solidFill>
+                  <a:srgbClr val="FFFFFF"/>
+                </a:solidFill>
+              </a:defRPr>
+            </a:pPr>
+          </a:p>
+          <a:p>
+            <a:pPr>
+              <a:spcAft>
+                <a:spcPts val="400"/>
+              </a:spcAft>
+              <a:defRPr sz="1500" b="0">
+                <a:solidFill>
+                  <a:srgbClr val="E8F5E9"/>
+                </a:solidFill>
+              </a:defRPr>
+            </a:pPr>
+            <a:r>
+              <a:t>Investment: $85M for 30% minority stake</a:t>
+            </a:r>
+          </a:p>
+          <a:p>
+            <a:pPr>
+              <a:spcAft>
+                <a:spcPts val="400"/>
+              </a:spcAft>
+              <a:defRPr sz="1500" b="0">
+                <a:solidFill>
+                  <a:srgbClr val="E8F5E9"/>
+                </a:solidFill>
+              </a:defRPr>
+            </a:pPr>
+            <a:r>
+              <a:t>Pre-money valuation: $283M</a:t>
+            </a:r>
+          </a:p>
+          <a:p>
+            <a:pPr>
+              <a:spcAft>
+                <a:spcPts val="400"/>
+              </a:spcAft>
+              <a:defRPr sz="1500" b="0">
+                <a:solidFill>
+                  <a:srgbClr val="E8F5E9"/>
+                </a:solidFill>
+              </a:defRPr>
+            </a:pPr>
+            <a:r>
+              <a:t>Post-money valuation: $368M</a:t>
+            </a:r>
+          </a:p>
+          <a:p>
+            <a:pPr>
+              <a:spcAft>
+                <a:spcPts val="400"/>
+              </a:spcAft>
+              <a:defRPr sz="1500" b="0">
+                <a:solidFill>
+                  <a:srgbClr val="E8F5E9"/>
+                </a:solidFill>
+              </a:defRPr>
+            </a:pPr>
+            <a:r>
+              <a:t>Type: Growth equity (profitable company)</a:t>
+            </a:r>
+          </a:p>
+          <a:p>
+            <a:pPr>
+              <a:spcAft>
+                <a:spcPts val="400"/>
+              </a:spcAft>
+              <a:defRPr sz="1500" b="0">
+                <a:solidFill>
+                  <a:srgbClr val="E8F5E9"/>
+                </a:solidFill>
+              </a:defRPr>
+            </a:pPr>
+            <a:r>
+              <a:t>Structure: Preferred equity + minority protections</a:t>
+            </a:r>
+          </a:p>
+        </p:txBody>
+      </p:sp>
+      <p:sp>
+        <p:nvSpPr>
+          <p:cNvPr id="4" name="TextBox 3"/>
+          <p:cNvSpPr txBox="1"/>
+          <p:nvPr/>
+        </p:nvSpPr>
+        <p:spPr>
+          <a:xfrm>
+            <a:off x="6400800" y="1097280"/>
+            <a:ext cx="5029200" cy="457200"/>
+          </a:xfrm>
+          <a:prstGeom prst="rect">
+            <a:avLst/>
+          </a:prstGeom>
+          <a:noFill/>
+        </p:spPr>
+        <p:txBody>
+          <a:bodyPr wrap="square">
+            <a:spAutoFit/>
+          </a:bodyPr>
+          <a:lstStyle/>
+          <a:p>
+            <a:pPr algn="l">
+              <a:defRPr sz="2000" b="1">
+                <a:solidFill>
+                  <a:srgbClr val="FFFFFF"/>
+                </a:solidFill>
+              </a:defRPr>
+            </a:pPr>
+            <a:r>
+              <a:t>Use of Proceeds ($85M)</a:t>
+            </a:r>
+          </a:p>
+        </p:txBody>
+      </p:sp>
+      <p:sp>
+        <p:nvSpPr>
+          <p:cNvPr id="5" name="TextBox 4"/>
+          <p:cNvSpPr txBox="1"/>
+          <p:nvPr/>
+        </p:nvSpPr>
+        <p:spPr>
+          <a:xfrm>
+            <a:off x="6400800" y="1828800"/>
+            <a:ext cx="1828800" cy="365760"/>
+          </a:xfrm>
+          <a:prstGeom prst="rect">
+            <a:avLst/>
+          </a:prstGeom>
+          <a:noFill/>
+        </p:spPr>
+        <p:txBody>
+          <a:bodyPr wrap="square">
+            <a:spAutoFit/>
+          </a:bodyPr>
+          <a:lstStyle/>
+          <a:p>
+            <a:pPr algn="l">
+              <a:defRPr sz="1400" b="1">
+                <a:solidFill>
+                  <a:srgbClr val="4CAF50"/>
+                </a:solidFill>
+              </a:defRPr>
+            </a:pPr>
+            <a:r>
+              <a:t>40%  |  $34M</a:t>
+            </a:r>
+          </a:p>
+        </p:txBody>
+      </p:sp>
+      <p:sp>
+        <p:nvSpPr>
+          <p:cNvPr id="6" name="TextBox 5"/>
+          <p:cNvSpPr txBox="1"/>
+          <p:nvPr/>
+        </p:nvSpPr>
+        <p:spPr>
+          <a:xfrm>
+            <a:off x="6400800" y="2194560"/>
+            <a:ext cx="5029200" cy="365760"/>
+          </a:xfrm>
+          <a:prstGeom prst="rect">
+            <a:avLst/>
+          </a:prstGeom>
+          <a:noFill/>
+        </p:spPr>
+        <p:txBody>
+          <a:bodyPr wrap="square">
+            <a:spAutoFit/>
+          </a:bodyPr>
+          <a:lstStyle/>
+          <a:p>
+            <a:pPr algn="l">
+              <a:defRPr sz="1600" b="1">
+                <a:solidFill>
+                  <a:srgbClr val="FFFFFF"/>
+                </a:solidFill>
+              </a:defRPr>
+            </a:pPr>
+            <a:r>
+              <a:t>European Expansion</a:t>
+            </a:r>
+          </a:p>
+        </p:txBody>
+      </p:sp>
+      <p:sp>
+        <p:nvSpPr>
+          <p:cNvPr id="7" name="TextBox 6"/>
+          <p:cNvSpPr txBox="1"/>
+          <p:nvPr/>
+        </p:nvSpPr>
+        <p:spPr>
+          <a:xfrm>
+            <a:off x="6400800" y="2560320"/>
+            <a:ext cx="5029200" cy="365760"/>
+          </a:xfrm>
+          <a:prstGeom prst="rect">
+            <a:avLst/>
+          </a:prstGeom>
+          <a:noFill/>
+        </p:spPr>
+        <p:txBody>
+          <a:bodyPr wrap="square">
+            <a:spAutoFit/>
+          </a:bodyPr>
+          <a:lstStyle/>
+          <a:p>
+            <a:pPr algn="l">
+              <a:defRPr sz="1200" b="0">
+                <a:solidFill>
+                  <a:srgbClr val="999999"/>
+                </a:solidFill>
+              </a:defRPr>
+            </a:pPr>
+            <a:r>
+              <a:t>London HQ, EU data centers, local GTM</a:t>
+            </a:r>
+          </a:p>
+        </p:txBody>
+      </p:sp>
+      <p:sp>
+        <p:nvSpPr>
+          <p:cNvPr id="8" name="TextBox 7"/>
+          <p:cNvSpPr txBox="1"/>
+          <p:nvPr/>
+        </p:nvSpPr>
+        <p:spPr>
+          <a:xfrm>
+            <a:off x="6400800" y="3108960"/>
+            <a:ext cx="1828800" cy="365760"/>
+          </a:xfrm>
+          <a:prstGeom prst="rect">
+            <a:avLst/>
+          </a:prstGeom>
+          <a:noFill/>
+        </p:spPr>
+        <p:txBody>
+          <a:bodyPr wrap="square">
+            <a:spAutoFit/>
+          </a:bodyPr>
+          <a:lstStyle/>
+          <a:p>
+            <a:pPr algn="l">
+              <a:defRPr sz="1400" b="1">
+                <a:solidFill>
+                  <a:srgbClr val="4CAF50"/>
+                </a:solidFill>
+              </a:defRPr>
+            </a:pPr>
+            <a:r>
+              <a:t>35%  |  $30M</a:t>
+            </a:r>
+          </a:p>
+        </p:txBody>
+      </p:sp>
+      <p:sp>
+        <p:nvSpPr>
+          <p:cNvPr id="9" name="TextBox 8"/>
+          <p:cNvSpPr txBox="1"/>
+          <p:nvPr/>
+        </p:nvSpPr>
+        <p:spPr>
+          <a:xfrm>
+            <a:off x="6400800" y="3474720"/>
+            <a:ext cx="5029200" cy="365760"/>
+          </a:xfrm>
+          <a:prstGeom prst="rect">
+            <a:avLst/>
+          </a:prstGeom>
+          <a:noFill/>
+        </p:spPr>
+        <p:txBody>
+          <a:bodyPr wrap="square">
+            <a:spAutoFit/>
+          </a:bodyPr>
+          <a:lstStyle/>
+          <a:p>
+            <a:pPr algn="l">
+              <a:defRPr sz="1600" b="1">
+                <a:solidFill>
+                  <a:srgbClr val="FFFFFF"/>
+                </a:solidFill>
+              </a:defRPr>
+            </a:pPr>
+            <a:r>
+              <a:t>Product Development</a:t>
+            </a:r>
+          </a:p>
+        </p:txBody>
+      </p:sp>
+      <p:sp>
+        <p:nvSpPr>
+          <p:cNvPr id="10" name="TextBox 9"/>
+          <p:cNvSpPr txBox="1"/>
+          <p:nvPr/>
+        </p:nvSpPr>
+        <p:spPr>
+          <a:xfrm>
+            <a:off x="6400800" y="3840480"/>
+            <a:ext cx="5029200" cy="365760"/>
+          </a:xfrm>
+          <a:prstGeom prst="rect">
+            <a:avLst/>
+          </a:prstGeom>
+          <a:noFill/>
+        </p:spPr>
+        <p:txBody>
+          <a:bodyPr wrap="square">
+            <a:spAutoFit/>
+          </a:bodyPr>
+          <a:lstStyle/>
+          <a:p>
+            <a:pPr algn="l">
+              <a:defRPr sz="1200" b="0">
+                <a:solidFill>
+                  <a:srgbClr val="999999"/>
+                </a:solidFill>
+              </a:defRPr>
+            </a:pPr>
+            <a:r>
+              <a:t>AI predictive analytics, 100 new integrations</a:t>
+            </a:r>
+          </a:p>
+        </p:txBody>
+      </p:sp>
+      <p:sp>
+        <p:nvSpPr>
+          <p:cNvPr id="11" name="TextBox 10"/>
+          <p:cNvSpPr txBox="1"/>
+          <p:nvPr/>
+        </p:nvSpPr>
+        <p:spPr>
+          <a:xfrm>
+            <a:off x="6400800" y="4389120"/>
+            <a:ext cx="1828800" cy="365760"/>
+          </a:xfrm>
+          <a:prstGeom prst="rect">
+            <a:avLst/>
+          </a:prstGeom>
+          <a:noFill/>
+        </p:spPr>
+        <p:txBody>
+          <a:bodyPr wrap="square">
+            <a:spAutoFit/>
+          </a:bodyPr>
+          <a:lstStyle/>
+          <a:p>
+            <a:pPr algn="l">
+              <a:defRPr sz="1400" b="1">
+                <a:solidFill>
+                  <a:srgbClr val="4CAF50"/>
+                </a:solidFill>
+              </a:defRPr>
+            </a:pPr>
+            <a:r>
+              <a:t>25%  |  $21M</a:t>
+            </a:r>
+          </a:p>
+        </p:txBody>
+      </p:sp>
+      <p:sp>
+        <p:nvSpPr>
+          <p:cNvPr id="12" name="TextBox 11"/>
+          <p:cNvSpPr txBox="1"/>
+          <p:nvPr/>
+        </p:nvSpPr>
+        <p:spPr>
+          <a:xfrm>
+            <a:off x="6400800" y="4754880"/>
+            <a:ext cx="5029200" cy="365760"/>
+          </a:xfrm>
+          <a:prstGeom prst="rect">
+            <a:avLst/>
+          </a:prstGeom>
+          <a:noFill/>
+        </p:spPr>
+        <p:txBody>
+          <a:bodyPr wrap="square">
+            <a:spAutoFit/>
+          </a:bodyPr>
+          <a:lstStyle/>
+          <a:p>
+            <a:pPr algn="l">
+              <a:defRPr sz="1600" b="1">
+                <a:solidFill>
+                  <a:srgbClr val="FFFFFF"/>
+                </a:solidFill>
+              </a:defRPr>
+            </a:pPr>
+            <a:r>
+              <a:t>Headcount Growth</a:t>
+            </a:r>
+          </a:p>
+        </p:txBody>
+      </p:sp>
+      <p:sp>
+        <p:nvSpPr>
+          <p:cNvPr id="13" name="TextBox 12"/>
+          <p:cNvSpPr txBox="1"/>
+          <p:nvPr/>
+        </p:nvSpPr>
+        <p:spPr>
+          <a:xfrm>
+            <a:off x="6400800" y="5120640"/>
+            <a:ext cx="5029200" cy="365760"/>
+          </a:xfrm>
+          <a:prstGeom prst="rect">
+            <a:avLst/>
+          </a:prstGeom>
+          <a:noFill/>
+        </p:spPr>
+        <p:txBody>
+          <a:bodyPr wrap="square">
+            <a:spAutoFit/>
+          </a:bodyPr>
+          <a:lstStyle/>
+          <a:p>
+            <a:pPr algn="l">
+              <a:defRPr sz="1200" b="0">
+                <a:solidFill>
+                  <a:srgbClr val="999999"/>
+                </a:solidFill>
+              </a:defRPr>
+            </a:pPr>
+            <a:r>
+              <a:t>120 → 200 employees, CS &amp; integration eng.</a:t>
+            </a:r>
+          </a:p>
+        </p:txBody>
+      </p:sp>
+    </p:spTree>
+  </p:cSld>
+  <p:clrMapOvr>
+    <a:masterClrMapping/>
+  </p:clrMapOvr>
+</p:sld>
+</file>
+
+<file path=ppt/slides/slide6.xml><?xml version="1.0" encoding="utf-8"?>
+<p:sld xmlns:a="http://schemas.openxmlformats.org/drawingml/2006/main" xmlns:p="http://schemas.openxmlformats.org/presentationml/2006/main" xmlns:r="http://schemas.openxmlformats.org/officeDocument/2006/relationships">
+  <p:cSld>
+    <p:bg>
+      <p:bgPr>
+        <a:solidFill>
+          <a:srgbClr val="0A1F0D"/>
+        </a:solidFill>
+        <a:effectLst/>
+      </p:bgPr>
+    </p:bg>
+    <p:spTree>
+      <p:nvGrpSpPr>
+        <p:cNvPr id="1" name=""/>
+        <p:cNvGrpSpPr/>
+        <p:nvPr/>
+      </p:nvGrpSpPr>
+      <p:grpSpPr/>
+      <p:sp>
+        <p:nvSpPr>
+          <p:cNvPr id="2" name="TextBox 1"/>
+          <p:cNvSpPr txBox="1"/>
+          <p:nvPr/>
+        </p:nvSpPr>
+        <p:spPr>
+          <a:xfrm>
+            <a:off x="731520" y="365760"/>
+            <a:ext cx="10058400" cy="640080"/>
+          </a:xfrm>
+          <a:prstGeom prst="rect">
+            <a:avLst/>
+          </a:prstGeom>
+          <a:noFill/>
+        </p:spPr>
+        <p:txBody>
+          <a:bodyPr wrap="square">
+            <a:spAutoFit/>
+          </a:bodyPr>
+          <a:lstStyle/>
+          <a:p>
+            <a:pPr algn="l">
+              <a:defRPr sz="1400" b="1">
+                <a:solidFill>
+                  <a:srgbClr val="4CAF50"/>
+                </a:solidFill>
+              </a:defRPr>
+            </a:pPr>
+            <a:r>
+              <a:t>KEY RISKS &amp; MITIGATIONS</a:t>
+            </a:r>
+          </a:p>
+        </p:txBody>
+      </p:sp>
+      <p:sp>
+        <p:nvSpPr>
+          <p:cNvPr id="3" name="TextBox 2"/>
+          <p:cNvSpPr txBox="1"/>
+          <p:nvPr/>
+        </p:nvSpPr>
+        <p:spPr>
+          <a:xfrm>
+            <a:off x="731520" y="1097280"/>
+            <a:ext cx="731520" cy="365760"/>
+          </a:xfrm>
+          <a:prstGeom prst="rect">
+            <a:avLst/>
+          </a:prstGeom>
+          <a:noFill/>
+        </p:spPr>
+        <p:txBody>
+          <a:bodyPr wrap="square">
+            <a:spAutoFit/>
+          </a:bodyPr>
+          <a:lstStyle/>
+          <a:p>
+            <a:pPr algn="ctr">
+              <a:defRPr sz="1200" b="1">
+                <a:solidFill>
+                  <a:srgbClr val="F44336"/>
+                </a:solidFill>
+              </a:defRPr>
+            </a:pPr>
+            <a:r>
+              <a:t>HIGH</a:t>
+            </a:r>
+          </a:p>
+        </p:txBody>
+      </p:sp>
+      <p:sp>
+        <p:nvSpPr>
+          <p:cNvPr id="4" name="TextBox 3"/>
+          <p:cNvSpPr txBox="1"/>
+          <p:nvPr/>
+        </p:nvSpPr>
+        <p:spPr>
+          <a:xfrm>
+            <a:off x="1554480" y="1097280"/>
+            <a:ext cx="2743200" cy="365760"/>
+          </a:xfrm>
+          <a:prstGeom prst="rect">
+            <a:avLst/>
+          </a:prstGeom>
+          <a:noFill/>
+        </p:spPr>
+        <p:txBody>
+          <a:bodyPr wrap="square">
+            <a:spAutoFit/>
+          </a:bodyPr>
+          <a:lstStyle/>
+          <a:p>
+            <a:pPr algn="l">
+              <a:defRPr sz="1500" b="1">
+                <a:solidFill>
+                  <a:srgbClr val="FFFFFF"/>
+                </a:solidFill>
+              </a:defRPr>
+            </a:pPr>
+            <a:r>
+              <a:t>Customer Concentration</a:t>
+            </a:r>
+          </a:p>
+        </p:txBody>
+      </p:sp>
+      <p:sp>
+        <p:nvSpPr>
+          <p:cNvPr id="5" name="TextBox 4"/>
+          <p:cNvSpPr txBox="1"/>
+          <p:nvPr/>
+        </p:nvSpPr>
+        <p:spPr>
+          <a:xfrm>
+            <a:off x="1554480" y="1463040"/>
+            <a:ext cx="4114800" cy="365760"/>
+          </a:xfrm>
+          <a:prstGeom prst="rect">
+            <a:avLst/>
+          </a:prstGeom>
+          <a:noFill/>
+        </p:spPr>
+        <p:txBody>
+          <a:bodyPr wrap="square">
+            <a:spAutoFit/>
+          </a:bodyPr>
+          <a:lstStyle/>
+          <a:p>
+            <a:pPr algn="l">
+              <a:defRPr sz="1100" b="0">
+                <a:solidFill>
+                  <a:srgbClr val="999999"/>
+                </a:solidFill>
+              </a:defRPr>
+            </a:pPr>
+            <a:r>
+              <a:t>Top 3 = 40% of ARR</a:t>
+            </a:r>
+          </a:p>
+        </p:txBody>
+      </p:sp>
+      <p:sp>
+        <p:nvSpPr>
+          <p:cNvPr id="6" name="TextBox 5"/>
+          <p:cNvSpPr txBox="1"/>
+          <p:nvPr/>
+        </p:nvSpPr>
+        <p:spPr>
+          <a:xfrm>
+            <a:off x="6400800" y="1097280"/>
+            <a:ext cx="5029200" cy="365760"/>
+          </a:xfrm>
+          <a:prstGeom prst="rect">
+            <a:avLst/>
+          </a:prstGeom>
+          <a:noFill/>
+        </p:spPr>
+        <p:txBody>
+          <a:bodyPr wrap="square">
+            <a:spAutoFit/>
+          </a:bodyPr>
+          <a:lstStyle/>
+          <a:p>
+            <a:pPr algn="l">
+              <a:defRPr sz="1100" b="1">
+                <a:solidFill>
+                  <a:srgbClr val="4CAF50"/>
+                </a:solidFill>
+              </a:defRPr>
+            </a:pPr>
+            <a:r>
+              <a:t>Mitigation:</a:t>
+            </a:r>
+          </a:p>
+        </p:txBody>
+      </p:sp>
+      <p:sp>
+        <p:nvSpPr>
+          <p:cNvPr id="7" name="TextBox 6"/>
+          <p:cNvSpPr txBox="1"/>
+          <p:nvPr/>
+        </p:nvSpPr>
+        <p:spPr>
+          <a:xfrm>
+            <a:off x="6400800" y="1417320"/>
+            <a:ext cx="5029200" cy="457200"/>
+          </a:xfrm>
+          <a:prstGeom prst="rect">
+            <a:avLst/>
+          </a:prstGeom>
+          <a:noFill/>
+        </p:spPr>
+        <p:txBody>
+          <a:bodyPr wrap="square">
+            <a:spAutoFit/>
+          </a:bodyPr>
+          <a:lstStyle/>
+          <a:p>
+            <a:pPr algn="l">
+              <a:defRPr sz="1200" b="0">
+                <a:solidFill>
+                  <a:srgbClr val="E8F5E9"/>
+                </a:solidFill>
+              </a:defRPr>
+            </a:pPr>
+            <a:r>
+              <a:t>Revenue diversification milestone in governance</a:t>
+            </a:r>
+          </a:p>
+        </p:txBody>
+      </p:sp>
+      <p:sp>
+        <p:nvSpPr>
+          <p:cNvPr id="8" name="TextBox 7"/>
+          <p:cNvSpPr txBox="1"/>
+          <p:nvPr/>
+        </p:nvSpPr>
+        <p:spPr>
+          <a:xfrm>
+            <a:off x="731520" y="2148839"/>
+            <a:ext cx="731520" cy="365760"/>
+          </a:xfrm>
+          <a:prstGeom prst="rect">
+            <a:avLst/>
+          </a:prstGeom>
+          <a:noFill/>
+        </p:spPr>
+        <p:txBody>
+          <a:bodyPr wrap="square">
+            <a:spAutoFit/>
+          </a:bodyPr>
+          <a:lstStyle/>
+          <a:p>
+            <a:pPr algn="ctr">
+              <a:defRPr sz="1200" b="1">
+                <a:solidFill>
+                  <a:srgbClr val="F44336"/>
+                </a:solidFill>
+              </a:defRPr>
+            </a:pPr>
+            <a:r>
+              <a:t>HIGH</a:t>
+            </a:r>
+          </a:p>
+        </p:txBody>
+      </p:sp>
+      <p:sp>
+        <p:nvSpPr>
+          <p:cNvPr id="9" name="TextBox 8"/>
+          <p:cNvSpPr txBox="1"/>
+          <p:nvPr/>
+        </p:nvSpPr>
+        <p:spPr>
+          <a:xfrm>
+            <a:off x="1554480" y="2148839"/>
+            <a:ext cx="2743200" cy="365760"/>
+          </a:xfrm>
+          <a:prstGeom prst="rect">
+            <a:avLst/>
+          </a:prstGeom>
+          <a:noFill/>
+        </p:spPr>
+        <p:txBody>
+          <a:bodyPr wrap="square">
+            <a:spAutoFit/>
+          </a:bodyPr>
+          <a:lstStyle/>
+          <a:p>
+            <a:pPr algn="l">
+              <a:defRPr sz="1500" b="1">
+                <a:solidFill>
+                  <a:srgbClr val="FFFFFF"/>
+                </a:solidFill>
+              </a:defRPr>
+            </a:pPr>
+            <a:r>
+              <a:t>Onboarding &amp; Support</a:t>
+            </a:r>
+          </a:p>
+        </p:txBody>
+      </p:sp>
+      <p:sp>
+        <p:nvSpPr>
+          <p:cNvPr id="10" name="TextBox 9"/>
+          <p:cNvSpPr txBox="1"/>
+          <p:nvPr/>
+        </p:nvSpPr>
+        <p:spPr>
+          <a:xfrm>
+            <a:off x="1554480" y="2514599"/>
+            <a:ext cx="4114800" cy="365760"/>
+          </a:xfrm>
+          <a:prstGeom prst="rect">
+            <a:avLst/>
+          </a:prstGeom>
+          <a:noFill/>
+        </p:spPr>
+        <p:txBody>
+          <a:bodyPr wrap="square">
+            <a:spAutoFit/>
+          </a:bodyPr>
+          <a:lstStyle/>
+          <a:p>
+            <a:pPr algn="l">
+              <a:defRPr sz="1100" b="0">
+                <a:solidFill>
+                  <a:srgbClr val="999999"/>
+                </a:solidFill>
+              </a:defRPr>
+            </a:pPr>
+            <a:r>
+              <a:t>4-month onboarding, support degradation post-Series A</a:t>
+            </a:r>
+          </a:p>
+        </p:txBody>
+      </p:sp>
+      <p:sp>
+        <p:nvSpPr>
+          <p:cNvPr id="11" name="TextBox 10"/>
+          <p:cNvSpPr txBox="1"/>
+          <p:nvPr/>
+        </p:nvSpPr>
+        <p:spPr>
+          <a:xfrm>
+            <a:off x="6400800" y="2148839"/>
+            <a:ext cx="5029200" cy="365760"/>
+          </a:xfrm>
+          <a:prstGeom prst="rect">
+            <a:avLst/>
+          </a:prstGeom>
+          <a:noFill/>
+        </p:spPr>
+        <p:txBody>
+          <a:bodyPr wrap="square">
+            <a:spAutoFit/>
+          </a:bodyPr>
+          <a:lstStyle/>
+          <a:p>
+            <a:pPr algn="l">
+              <a:defRPr sz="1100" b="1">
+                <a:solidFill>
+                  <a:srgbClr val="4CAF50"/>
+                </a:solidFill>
+              </a:defRPr>
+            </a:pPr>
+            <a:r>
+              <a:t>Mitigation:</a:t>
+            </a:r>
+          </a:p>
+        </p:txBody>
+      </p:sp>
+      <p:sp>
+        <p:nvSpPr>
+          <p:cNvPr id="12" name="TextBox 11"/>
+          <p:cNvSpPr txBox="1"/>
+          <p:nvPr/>
+        </p:nvSpPr>
+        <p:spPr>
+          <a:xfrm>
+            <a:off x="6400800" y="2468879"/>
+            <a:ext cx="5029200" cy="457200"/>
+          </a:xfrm>
+          <a:prstGeom prst="rect">
+            <a:avLst/>
+          </a:prstGeom>
+          <a:noFill/>
+        </p:spPr>
+        <p:txBody>
+          <a:bodyPr wrap="square">
+            <a:spAutoFit/>
+          </a:bodyPr>
+          <a:lstStyle/>
+          <a:p>
+            <a:pPr algn="l">
+              <a:defRPr sz="1200" b="0">
+                <a:solidFill>
+                  <a:srgbClr val="E8F5E9"/>
+                </a:solidFill>
+              </a:defRPr>
+            </a:pPr>
+            <a:r>
+              <a:t>Tranche tied to CS/support hiring milestones</a:t>
+            </a:r>
+          </a:p>
+        </p:txBody>
+      </p:sp>
+      <p:sp>
+        <p:nvSpPr>
+          <p:cNvPr id="13" name="TextBox 12"/>
+          <p:cNvSpPr txBox="1"/>
+          <p:nvPr/>
+        </p:nvSpPr>
+        <p:spPr>
+          <a:xfrm>
+            <a:off x="731520" y="3200400"/>
+            <a:ext cx="731520" cy="365760"/>
+          </a:xfrm>
+          <a:prstGeom prst="rect">
+            <a:avLst/>
+          </a:prstGeom>
+          <a:noFill/>
+        </p:spPr>
+        <p:txBody>
+          <a:bodyPr wrap="square">
+            <a:spAutoFit/>
+          </a:bodyPr>
+          <a:lstStyle/>
+          <a:p>
+            <a:pPr algn="ctr">
+              <a:defRPr sz="1200" b="1">
+                <a:solidFill>
+                  <a:srgbClr val="FF9800"/>
+                </a:solidFill>
+              </a:defRPr>
+            </a:pPr>
+            <a:r>
+              <a:t>MED</a:t>
+            </a:r>
+          </a:p>
+        </p:txBody>
+      </p:sp>
+      <p:sp>
+        <p:nvSpPr>
+          <p:cNvPr id="14" name="TextBox 13"/>
+          <p:cNvSpPr txBox="1"/>
+          <p:nvPr/>
+        </p:nvSpPr>
+        <p:spPr>
+          <a:xfrm>
+            <a:off x="1554480" y="3200400"/>
+            <a:ext cx="2743200" cy="365760"/>
+          </a:xfrm>
+          <a:prstGeom prst="rect">
+            <a:avLst/>
+          </a:prstGeom>
+          <a:noFill/>
+        </p:spPr>
+        <p:txBody>
+          <a:bodyPr wrap="square">
+            <a:spAutoFit/>
+          </a:bodyPr>
+          <a:lstStyle/>
+          <a:p>
+            <a:pPr algn="l">
+              <a:defRPr sz="1500" b="1">
+                <a:solidFill>
+                  <a:srgbClr val="FFFFFF"/>
+                </a:solidFill>
+              </a:defRPr>
+            </a:pPr>
+            <a:r>
+              <a:t>Pricing Strategy</a:t>
+            </a:r>
+          </a:p>
+        </p:txBody>
+      </p:sp>
+      <p:sp>
+        <p:nvSpPr>
+          <p:cNvPr id="15" name="TextBox 14"/>
+          <p:cNvSpPr txBox="1"/>
+          <p:nvPr/>
+        </p:nvSpPr>
+        <p:spPr>
+          <a:xfrm>
+            <a:off x="1554480" y="3566160"/>
+            <a:ext cx="4114800" cy="365760"/>
+          </a:xfrm>
+          <a:prstGeom prst="rect">
+            <a:avLst/>
+          </a:prstGeom>
+          <a:noFill/>
+        </p:spPr>
+        <p:txBody>
+          <a:bodyPr wrap="square">
+            <a:spAutoFit/>
+          </a:bodyPr>
+          <a:lstStyle/>
+          <a:p>
+            <a:pPr algn="l">
+              <a:defRPr sz="1100" b="0">
+                <a:solidFill>
+                  <a:srgbClr val="999999"/>
+                </a:solidFill>
+              </a:defRPr>
+            </a:pPr>
+            <a:r>
+              <a:t>40% price jump caused churn at Cornerstone</a:t>
+            </a:r>
+          </a:p>
+        </p:txBody>
+      </p:sp>
+      <p:sp>
+        <p:nvSpPr>
+          <p:cNvPr id="16" name="TextBox 15"/>
+          <p:cNvSpPr txBox="1"/>
+          <p:nvPr/>
+        </p:nvSpPr>
+        <p:spPr>
+          <a:xfrm>
+            <a:off x="6400800" y="3200400"/>
+            <a:ext cx="5029200" cy="365760"/>
+          </a:xfrm>
+          <a:prstGeom prst="rect">
+            <a:avLst/>
+          </a:prstGeom>
+          <a:noFill/>
+        </p:spPr>
+        <p:txBody>
+          <a:bodyPr wrap="square">
+            <a:spAutoFit/>
+          </a:bodyPr>
+          <a:lstStyle/>
+          <a:p>
+            <a:pPr algn="l">
+              <a:defRPr sz="1100" b="1">
+                <a:solidFill>
+                  <a:srgbClr val="4CAF50"/>
+                </a:solidFill>
+              </a:defRPr>
+            </a:pPr>
+            <a:r>
+              <a:t>Mitigation:</a:t>
+            </a:r>
+          </a:p>
+        </p:txBody>
+      </p:sp>
+      <p:sp>
+        <p:nvSpPr>
+          <p:cNvPr id="17" name="TextBox 16"/>
+          <p:cNvSpPr txBox="1"/>
+          <p:nvPr/>
+        </p:nvSpPr>
+        <p:spPr>
+          <a:xfrm>
+            <a:off x="6400800" y="3520440"/>
+            <a:ext cx="5029200" cy="457200"/>
+          </a:xfrm>
+          <a:prstGeom prst="rect">
+            <a:avLst/>
+          </a:prstGeom>
+          <a:noFill/>
+        </p:spPr>
+        <p:txBody>
+          <a:bodyPr wrap="square">
+            <a:spAutoFit/>
+          </a:bodyPr>
+          <a:lstStyle/>
+          <a:p>
+            <a:pPr algn="l">
+              <a:defRPr sz="1200" b="0">
+                <a:solidFill>
+                  <a:srgbClr val="E8F5E9"/>
+                </a:solidFill>
+              </a:defRPr>
+            </a:pPr>
+            <a:r>
+              <a:t>Review pricing clauses in top 5 contracts</a:t>
+            </a:r>
+          </a:p>
+        </p:txBody>
+      </p:sp>
+      <p:sp>
+        <p:nvSpPr>
+          <p:cNvPr id="18" name="TextBox 17"/>
+          <p:cNvSpPr txBox="1"/>
+          <p:nvPr/>
+        </p:nvSpPr>
+        <p:spPr>
+          <a:xfrm>
+            <a:off x="731520" y="4251959"/>
+            <a:ext cx="731520" cy="365760"/>
+          </a:xfrm>
+          <a:prstGeom prst="rect">
+            <a:avLst/>
+          </a:prstGeom>
+          <a:noFill/>
+        </p:spPr>
+        <p:txBody>
+          <a:bodyPr wrap="square">
+            <a:spAutoFit/>
+          </a:bodyPr>
+          <a:lstStyle/>
+          <a:p>
+            <a:pPr algn="ctr">
+              <a:defRPr sz="1200" b="1">
+                <a:solidFill>
+                  <a:srgbClr val="FF9800"/>
+                </a:solidFill>
+              </a:defRPr>
+            </a:pPr>
+            <a:r>
+              <a:t>MED</a:t>
+            </a:r>
+          </a:p>
+        </p:txBody>
+      </p:sp>
+      <p:sp>
+        <p:nvSpPr>
+          <p:cNvPr id="19" name="TextBox 18"/>
+          <p:cNvSpPr txBox="1"/>
+          <p:nvPr/>
+        </p:nvSpPr>
+        <p:spPr>
+          <a:xfrm>
+            <a:off x="1554480" y="4251959"/>
+            <a:ext cx="2743200" cy="365760"/>
+          </a:xfrm>
+          <a:prstGeom prst="rect">
+            <a:avLst/>
+          </a:prstGeom>
+          <a:noFill/>
+        </p:spPr>
+        <p:txBody>
+          <a:bodyPr wrap="square">
+            <a:spAutoFit/>
+          </a:bodyPr>
+          <a:lstStyle/>
+          <a:p>
+            <a:pPr algn="l">
+              <a:defRPr sz="1500" b="1">
+                <a:solidFill>
+                  <a:srgbClr val="FFFFFF"/>
+                </a:solidFill>
+              </a:defRPr>
+            </a:pPr>
+            <a:r>
+              <a:t>SOC 2 Type II Gap</a:t>
+            </a:r>
+          </a:p>
+        </p:txBody>
+      </p:sp>
+      <p:sp>
+        <p:nvSpPr>
+          <p:cNvPr id="20" name="TextBox 19"/>
+          <p:cNvSpPr txBox="1"/>
+          <p:nvPr/>
+        </p:nvSpPr>
+        <p:spPr>
+          <a:xfrm>
+            <a:off x="1554480" y="4617719"/>
+            <a:ext cx="4114800" cy="365760"/>
+          </a:xfrm>
+          <a:prstGeom prst="rect">
+            <a:avLst/>
+          </a:prstGeom>
+          <a:noFill/>
+        </p:spPr>
+        <p:txBody>
+          <a:bodyPr wrap="square">
+            <a:spAutoFit/>
+          </a:bodyPr>
+          <a:lstStyle/>
+          <a:p>
+            <a:pPr algn="l">
+              <a:defRPr sz="1100" b="0">
+                <a:solidFill>
+                  <a:srgbClr val="999999"/>
+                </a:solidFill>
+              </a:defRPr>
+            </a:pPr>
+            <a:r>
+              <a:t>Only Type I; Avalon threatening to halt expansion</a:t>
+            </a:r>
+          </a:p>
+        </p:txBody>
+      </p:sp>
+      <p:sp>
+        <p:nvSpPr>
+          <p:cNvPr id="21" name="TextBox 20"/>
+          <p:cNvSpPr txBox="1"/>
+          <p:nvPr/>
+        </p:nvSpPr>
+        <p:spPr>
+          <a:xfrm>
+            <a:off x="6400800" y="4251959"/>
+            <a:ext cx="5029200" cy="365760"/>
+          </a:xfrm>
+          <a:prstGeom prst="rect">
+            <a:avLst/>
+          </a:prstGeom>
+          <a:noFill/>
+        </p:spPr>
+        <p:txBody>
+          <a:bodyPr wrap="square">
+            <a:spAutoFit/>
+          </a:bodyPr>
+          <a:lstStyle/>
+          <a:p>
+            <a:pPr algn="l">
+              <a:defRPr sz="1100" b="1">
+                <a:solidFill>
+                  <a:srgbClr val="4CAF50"/>
+                </a:solidFill>
+              </a:defRPr>
+            </a:pPr>
+            <a:r>
+              <a:t>Mitigation:</a:t>
+            </a:r>
+          </a:p>
+        </p:txBody>
+      </p:sp>
+      <p:sp>
+        <p:nvSpPr>
+          <p:cNvPr id="22" name="TextBox 21"/>
+          <p:cNvSpPr txBox="1"/>
+          <p:nvPr/>
+        </p:nvSpPr>
+        <p:spPr>
+          <a:xfrm>
+            <a:off x="6400800" y="4571999"/>
+            <a:ext cx="5029200" cy="457200"/>
+          </a:xfrm>
+          <a:prstGeom prst="rect">
+            <a:avLst/>
+          </a:prstGeom>
+          <a:noFill/>
+        </p:spPr>
+        <p:txBody>
+          <a:bodyPr wrap="square">
+            <a:spAutoFit/>
+          </a:bodyPr>
+          <a:lstStyle/>
+          <a:p>
+            <a:pPr algn="l">
+              <a:defRPr sz="1200" b="0">
+                <a:solidFill>
+                  <a:srgbClr val="E8F5E9"/>
+                </a:solidFill>
+              </a:defRPr>
+            </a:pPr>
+            <a:r>
+              <a:t>Make Type II completion a closing condition</a:t>
+            </a:r>
+          </a:p>
+        </p:txBody>
+      </p:sp>
+      <p:sp>
+        <p:nvSpPr>
+          <p:cNvPr id="23" name="TextBox 22"/>
+          <p:cNvSpPr txBox="1"/>
+          <p:nvPr/>
+        </p:nvSpPr>
+        <p:spPr>
+          <a:xfrm>
+            <a:off x="731520" y="5303520"/>
+            <a:ext cx="731520" cy="365760"/>
+          </a:xfrm>
+          <a:prstGeom prst="rect">
+            <a:avLst/>
+          </a:prstGeom>
+          <a:noFill/>
+        </p:spPr>
+        <p:txBody>
+          <a:bodyPr wrap="square">
+            <a:spAutoFit/>
+          </a:bodyPr>
+          <a:lstStyle/>
+          <a:p>
+            <a:pPr algn="ctr">
+              <a:defRPr sz="1200" b="1">
+                <a:solidFill>
+                  <a:srgbClr val="4CAF50"/>
+                </a:solidFill>
+              </a:defRPr>
+            </a:pPr>
+            <a:r>
+              <a:t>LOW</a:t>
+            </a:r>
+          </a:p>
+        </p:txBody>
+      </p:sp>
+      <p:sp>
+        <p:nvSpPr>
+          <p:cNvPr id="24" name="TextBox 23"/>
+          <p:cNvSpPr txBox="1"/>
+          <p:nvPr/>
+        </p:nvSpPr>
+        <p:spPr>
+          <a:xfrm>
+            <a:off x="1554480" y="5303520"/>
+            <a:ext cx="2743200" cy="365760"/>
+          </a:xfrm>
+          <a:prstGeom prst="rect">
+            <a:avLst/>
+          </a:prstGeom>
+          <a:noFill/>
+        </p:spPr>
+        <p:txBody>
+          <a:bodyPr wrap="square">
+            <a:spAutoFit/>
+          </a:bodyPr>
+          <a:lstStyle/>
+          <a:p>
+            <a:pPr algn="l">
+              <a:defRPr sz="1500" b="1">
+                <a:solidFill>
+                  <a:srgbClr val="FFFFFF"/>
+                </a:solidFill>
+              </a:defRPr>
+            </a:pPr>
+            <a:r>
+              <a:t>Key Person Risk</a:t>
+            </a:r>
+          </a:p>
+        </p:txBody>
+      </p:sp>
+      <p:sp>
+        <p:nvSpPr>
+          <p:cNvPr id="25" name="TextBox 24"/>
+          <p:cNvSpPr txBox="1"/>
+          <p:nvPr/>
+        </p:nvSpPr>
+        <p:spPr>
+          <a:xfrm>
+            <a:off x="1554480" y="5669280"/>
+            <a:ext cx="4114800" cy="365760"/>
+          </a:xfrm>
+          <a:prstGeom prst="rect">
+            <a:avLst/>
+          </a:prstGeom>
+          <a:noFill/>
+        </p:spPr>
+        <p:txBody>
+          <a:bodyPr wrap="square">
+            <a:spAutoFit/>
+          </a:bodyPr>
+          <a:lstStyle/>
+          <a:p>
+            <a:pPr algn="l">
+              <a:defRPr sz="1100" b="0">
+                <a:solidFill>
+                  <a:srgbClr val="999999"/>
+                </a:solidFill>
+              </a:defRPr>
+            </a:pPr>
+            <a:r>
+              <a:t>Domain expertise in CEO + CTO</a:t>
+            </a:r>
+          </a:p>
+        </p:txBody>
+      </p:sp>
+      <p:sp>
+        <p:nvSpPr>
+          <p:cNvPr id="26" name="TextBox 25"/>
+          <p:cNvSpPr txBox="1"/>
+          <p:nvPr/>
+        </p:nvSpPr>
+        <p:spPr>
+          <a:xfrm>
+            <a:off x="6400800" y="5303520"/>
+            <a:ext cx="5029200" cy="365760"/>
+          </a:xfrm>
+          <a:prstGeom prst="rect">
+            <a:avLst/>
+          </a:prstGeom>
+          <a:noFill/>
+        </p:spPr>
+        <p:txBody>
+          <a:bodyPr wrap="square">
+            <a:spAutoFit/>
+          </a:bodyPr>
+          <a:lstStyle/>
+          <a:p>
+            <a:pPr algn="l">
+              <a:defRPr sz="1100" b="1">
+                <a:solidFill>
+                  <a:srgbClr val="4CAF50"/>
+                </a:solidFill>
+              </a:defRPr>
+            </a:pPr>
+            <a:r>
+              <a:t>Mitigation:</a:t>
+            </a:r>
+          </a:p>
+        </p:txBody>
+      </p:sp>
+      <p:sp>
+        <p:nvSpPr>
+          <p:cNvPr id="27" name="TextBox 26"/>
+          <p:cNvSpPr txBox="1"/>
+          <p:nvPr/>
+        </p:nvSpPr>
+        <p:spPr>
+          <a:xfrm>
+            <a:off x="6400800" y="5623560"/>
+            <a:ext cx="5029200" cy="457200"/>
+          </a:xfrm>
+          <a:prstGeom prst="rect">
+            <a:avLst/>
+          </a:prstGeom>
+          <a:noFill/>
+        </p:spPr>
+        <p:txBody>
+          <a:bodyPr wrap="square">
+            <a:spAutoFit/>
+          </a:bodyPr>
+          <a:lstStyle/>
+          <a:p>
+            <a:pPr algn="l">
+              <a:defRPr sz="1200" b="0">
+                <a:solidFill>
+                  <a:srgbClr val="E8F5E9"/>
+                </a:solidFill>
+              </a:defRPr>
+            </a:pPr>
+            <a:r>
+              <a:t>Key-person insurance &amp; retention packages</a:t>
+            </a:r>
+          </a:p>
+        </p:txBody>
+      </p:sp>
+    </p:spTree>
+  </p:cSld>
+  <p:clrMapOvr>
+    <a:masterClrMapping/>
+  </p:clrMapOvr>
+</p:sld>
+</file>
+
+<file path=ppt/slides/slide7.xml><?xml version="1.0" encoding="utf-8"?>
+<p:sld xmlns:a="http://schemas.openxmlformats.org/drawingml/2006/main" xmlns:p="http://schemas.openxmlformats.org/presentationml/2006/main" xmlns:r="http://schemas.openxmlformats.org/officeDocument/2006/relationships">
+  <p:cSld>
+    <p:bg>
+      <p:bgPr>
+        <a:solidFill>
+          <a:srgbClr val="0A1F0D"/>
+        </a:solidFill>
+        <a:effectLst/>
+      </p:bgPr>
+    </p:bg>
+    <p:spTree>
+      <p:nvGrpSpPr>
+        <p:cNvPr id="1" name=""/>
+        <p:cNvGrpSpPr/>
+        <p:nvPr/>
+      </p:nvGrpSpPr>
+      <p:grpSpPr/>
+      <p:sp>
+        <p:nvSpPr>
+          <p:cNvPr id="2" name="TextBox 1"/>
+          <p:cNvSpPr txBox="1"/>
+          <p:nvPr/>
+        </p:nvSpPr>
+        <p:spPr>
+          <a:xfrm>
+            <a:off x="914400" y="1828800"/>
+            <a:ext cx="10058400" cy="914400"/>
+          </a:xfrm>
+          <a:prstGeom prst="rect">
+            <a:avLst/>
+          </a:prstGeom>
+          <a:noFill/>
+        </p:spPr>
+        <p:txBody>
+          <a:bodyPr wrap="square">
+            <a:spAutoFit/>
+          </a:bodyPr>
+          <a:lstStyle/>
+          <a:p>
+            <a:pPr algn="ctr">
+              <a:defRPr sz="4000" b="1">
+                <a:solidFill>
+                  <a:srgbClr val="FFFFFF"/>
+                </a:solidFill>
+              </a:defRPr>
+            </a:pPr>
+            <a:r>
+              <a:t>Recommendation: Invest</a:t>
+            </a:r>
+          </a:p>
+        </p:txBody>
+      </p:sp>
+      <p:sp>
+        <p:nvSpPr>
+          <p:cNvPr id="3" name="TextBox 2"/>
+          <p:cNvSpPr txBox="1"/>
+          <p:nvPr/>
+        </p:nvSpPr>
+        <p:spPr>
+          <a:xfrm>
+            <a:off x="914400" y="2926080"/>
+            <a:ext cx="10058400" cy="731520"/>
+          </a:xfrm>
+          <a:prstGeom prst="rect">
+            <a:avLst/>
+          </a:prstGeom>
+          <a:noFill/>
+        </p:spPr>
+        <p:txBody>
+          <a:bodyPr wrap="square">
+            <a:spAutoFit/>
+          </a:bodyPr>
+          <a:lstStyle/>
+          <a:p>
+            <a:pPr algn="ctr">
+              <a:defRPr sz="2200" b="0">
+                <a:solidFill>
+                  <a:srgbClr val="4CAF50"/>
+                </a:solidFill>
+              </a:defRPr>
+            </a:pPr>
+            <a:r>
+              <a:t>$85M  |  30% Stake  |  $283M Pre-Money  |  ~9.1x ARR</a:t>
+            </a:r>
+          </a:p>
+        </p:txBody>
+      </p:sp>
+      <p:sp>
+        <p:nvSpPr>
+          <p:cNvPr id="4" name="TextBox 3"/>
+          <p:cNvSpPr txBox="1"/>
+          <p:nvPr/>
+        </p:nvSpPr>
+        <p:spPr>
+          <a:xfrm>
+            <a:off x="914400" y="4114800"/>
+            <a:ext cx="10058400" cy="914400"/>
+          </a:xfrm>
+          <a:prstGeom prst="rect">
+            <a:avLst/>
+          </a:prstGeom>
+          <a:noFill/>
+        </p:spPr>
+        <p:txBody>
+          <a:bodyPr wrap="square">
+            <a:spAutoFit/>
+          </a:bodyPr>
+          <a:lstStyle/>
+          <a:p>
+            <a:pPr algn="ctr">
+              <a:defRPr sz="1800" b="0">
+                <a:solidFill>
+                  <a:srgbClr val="E8F5E9"/>
+                </a:solidFill>
+              </a:defRPr>
+            </a:pPr>
+            <a:r>
+              <a:t>NovaCrest Analytics — The Financial Data Infrastructure Layer</a:t>
+            </a:r>
+          </a:p>
+        </p:txBody>
+      </p:sp>
+      <p:sp>
+        <p:nvSpPr>
+          <p:cNvPr id="5" name="TextBox 4"/>
+          <p:cNvSpPr txBox="1"/>
+          <p:nvPr/>
+        </p:nvSpPr>
+        <p:spPr>
+          <a:xfrm>
+            <a:off x="914400" y="5486400"/>
+            <a:ext cx="10058400" cy="457200"/>
+          </a:xfrm>
+          <a:prstGeom prst="rect">
+            <a:avLst/>
+          </a:prstGeom>
+          <a:noFill/>
+        </p:spPr>
+        <p:txBody>
+          <a:bodyPr wrap="square">
+            <a:spAutoFit/>
+          </a:bodyPr>
+          <a:lstStyle/>
+          <a:p>
+            <a:pPr algn="ctr">
+              <a:defRPr sz="1100" b="0">
+                <a:solidFill>
+                  <a:srgbClr val="999999"/>
+                </a:solidFill>
+              </a:defRPr>
+            </a:pPr>
+            <a:r>
+              <a:t>Generated by Tracelight  |  AI-Powered Due Diligence Sidecar  |  All citations traceable to source documents</a:t>
             </a:r>
           </a:p>
         </p:txBody>

</xml_diff>